<commit_message>
make updates/adjustments to doc and ppt with recent progress
</commit_message>
<xml_diff>
--- a/Project Figures and Tables in order.pptx
+++ b/Project Figures and Tables in order.pptx
@@ -7,14 +7,16 @@
   <p:sldIdLst>
     <p:sldId id="256" r:id="rId2"/>
     <p:sldId id="257" r:id="rId3"/>
-    <p:sldId id="260" r:id="rId4"/>
-    <p:sldId id="258" r:id="rId5"/>
-    <p:sldId id="259" r:id="rId6"/>
-    <p:sldId id="261" r:id="rId7"/>
-    <p:sldId id="262" r:id="rId8"/>
-    <p:sldId id="263" r:id="rId9"/>
-    <p:sldId id="264" r:id="rId10"/>
-    <p:sldId id="265" r:id="rId11"/>
+    <p:sldId id="266" r:id="rId4"/>
+    <p:sldId id="267" r:id="rId5"/>
+    <p:sldId id="260" r:id="rId6"/>
+    <p:sldId id="258" r:id="rId7"/>
+    <p:sldId id="259" r:id="rId8"/>
+    <p:sldId id="261" r:id="rId9"/>
+    <p:sldId id="262" r:id="rId10"/>
+    <p:sldId id="263" r:id="rId11"/>
+    <p:sldId id="264" r:id="rId12"/>
+    <p:sldId id="265" r:id="rId13"/>
   </p:sldIdLst>
   <p:sldSz cx="12192000" cy="6858000"/>
   <p:notesSz cx="6858000" cy="9144000"/>
@@ -113,15 +115,12 @@
       </a:defRPr>
     </a:lvl9pPr>
   </p:defaultTextStyle>
+  <p:extLst>
+    <p:ext uri="{EFAFB233-063F-42B5-8137-9DF3F51BA10A}">
+      <p15:sldGuideLst xmlns:p15="http://schemas.microsoft.com/office/powerpoint/2012/main"/>
+    </p:ext>
+  </p:extLst>
 </p:presentation>
-</file>
-
-<file path=ppt/revisionInfo.xml><?xml version="1.0" encoding="utf-8"?>
-<p1510:revInfo xmlns:a="http://schemas.openxmlformats.org/drawingml/2006/main" xmlns:r="http://schemas.openxmlformats.org/officeDocument/2006/relationships" xmlns:p1510="http://schemas.microsoft.com/office/powerpoint/2015/10/main">
-  <p1510:revLst>
-    <p1510:client id="{BD7FD033-AE7A-42AD-8267-2A3E028CA24F}" v="2" dt="2026-07-20T15:44:05.308"/>
-  </p1510:revLst>
-</p1510:revInfo>
 </file>
 
 <file path=ppt/changesInfos/changesInfo1.xml><?xml version="1.0" encoding="utf-8"?>
@@ -129,7 +128,7 @@
   <pc:docChgLst>
     <pc:chgData name="McCloskey, Ross" userId="b1990487-ee44-4922-b58f-5b2980a02730" providerId="ADAL" clId="{7D443C21-FD7D-4E65-8C72-B41829F67170}"/>
     <pc:docChg chg="undo custSel addSld delSld modSld sldOrd">
-      <pc:chgData name="McCloskey, Ross" userId="b1990487-ee44-4922-b58f-5b2980a02730" providerId="ADAL" clId="{7D443C21-FD7D-4E65-8C72-B41829F67170}" dt="2026-07-20T16:09:41.479" v="2457" actId="1076"/>
+      <pc:chgData name="McCloskey, Ross" userId="b1990487-ee44-4922-b58f-5b2980a02730" providerId="ADAL" clId="{7D443C21-FD7D-4E65-8C72-B41829F67170}" dt="2026-08-05T19:56:16.129" v="3723" actId="47"/>
       <pc:docMkLst>
         <pc:docMk/>
       </pc:docMkLst>
@@ -139,70 +138,6 @@
           <pc:docMk/>
           <pc:sldMk cId="3129493839" sldId="256"/>
         </pc:sldMkLst>
-        <pc:spChg chg="del">
-          <ac:chgData name="McCloskey, Ross" userId="b1990487-ee44-4922-b58f-5b2980a02730" providerId="ADAL" clId="{7D443C21-FD7D-4E65-8C72-B41829F67170}" dt="2026-07-20T15:41:42.199" v="1" actId="700"/>
-          <ac:spMkLst>
-            <pc:docMk/>
-            <pc:sldMk cId="3129493839" sldId="256"/>
-            <ac:spMk id="2" creationId="{FFF51014-B5E2-1261-C81C-B349A193D004}"/>
-          </ac:spMkLst>
-        </pc:spChg>
-        <pc:spChg chg="del">
-          <ac:chgData name="McCloskey, Ross" userId="b1990487-ee44-4922-b58f-5b2980a02730" providerId="ADAL" clId="{7D443C21-FD7D-4E65-8C72-B41829F67170}" dt="2026-07-20T15:41:42.199" v="1" actId="700"/>
-          <ac:spMkLst>
-            <pc:docMk/>
-            <pc:sldMk cId="3129493839" sldId="256"/>
-            <ac:spMk id="3" creationId="{94EFA8FF-7DB8-5B54-C298-21B67EB435AB}"/>
-          </ac:spMkLst>
-        </pc:spChg>
-        <pc:spChg chg="add del mod ord">
-          <ac:chgData name="McCloskey, Ross" userId="b1990487-ee44-4922-b58f-5b2980a02730" providerId="ADAL" clId="{7D443C21-FD7D-4E65-8C72-B41829F67170}" dt="2026-07-20T15:42:16.510" v="3" actId="700"/>
-          <ac:spMkLst>
-            <pc:docMk/>
-            <pc:sldMk cId="3129493839" sldId="256"/>
-            <ac:spMk id="4" creationId="{9FC70FD3-BB19-2E22-3C45-BC398BD1F24B}"/>
-          </ac:spMkLst>
-        </pc:spChg>
-        <pc:spChg chg="add del mod ord">
-          <ac:chgData name="McCloskey, Ross" userId="b1990487-ee44-4922-b58f-5b2980a02730" providerId="ADAL" clId="{7D443C21-FD7D-4E65-8C72-B41829F67170}" dt="2026-07-20T15:42:16.510" v="3" actId="700"/>
-          <ac:spMkLst>
-            <pc:docMk/>
-            <pc:sldMk cId="3129493839" sldId="256"/>
-            <ac:spMk id="5" creationId="{112549ED-F713-223B-3144-6879EE06892E}"/>
-          </ac:spMkLst>
-        </pc:spChg>
-        <pc:spChg chg="add del mod ord">
-          <ac:chgData name="McCloskey, Ross" userId="b1990487-ee44-4922-b58f-5b2980a02730" providerId="ADAL" clId="{7D443C21-FD7D-4E65-8C72-B41829F67170}" dt="2026-07-20T15:42:23.855" v="4" actId="700"/>
-          <ac:spMkLst>
-            <pc:docMk/>
-            <pc:sldMk cId="3129493839" sldId="256"/>
-            <ac:spMk id="6" creationId="{D01DA712-273D-4768-B58D-48C41743C6F2}"/>
-          </ac:spMkLst>
-        </pc:spChg>
-        <pc:spChg chg="add del mod ord">
-          <ac:chgData name="McCloskey, Ross" userId="b1990487-ee44-4922-b58f-5b2980a02730" providerId="ADAL" clId="{7D443C21-FD7D-4E65-8C72-B41829F67170}" dt="2026-07-20T15:42:23.855" v="4" actId="700"/>
-          <ac:spMkLst>
-            <pc:docMk/>
-            <pc:sldMk cId="3129493839" sldId="256"/>
-            <ac:spMk id="7" creationId="{F84953BB-E5DB-C63F-A778-2DFB1B51BA9D}"/>
-          </ac:spMkLst>
-        </pc:spChg>
-        <pc:spChg chg="add del mod ord">
-          <ac:chgData name="McCloskey, Ross" userId="b1990487-ee44-4922-b58f-5b2980a02730" providerId="ADAL" clId="{7D443C21-FD7D-4E65-8C72-B41829F67170}" dt="2026-07-20T15:42:29.049" v="5" actId="700"/>
-          <ac:spMkLst>
-            <pc:docMk/>
-            <pc:sldMk cId="3129493839" sldId="256"/>
-            <ac:spMk id="8" creationId="{D59E5AA2-1C09-DAEB-3C59-B175457FE407}"/>
-          </ac:spMkLst>
-        </pc:spChg>
-        <pc:spChg chg="add del mod ord">
-          <ac:chgData name="McCloskey, Ross" userId="b1990487-ee44-4922-b58f-5b2980a02730" providerId="ADAL" clId="{7D443C21-FD7D-4E65-8C72-B41829F67170}" dt="2026-07-20T15:42:29.049" v="5" actId="700"/>
-          <ac:spMkLst>
-            <pc:docMk/>
-            <pc:sldMk cId="3129493839" sldId="256"/>
-            <ac:spMk id="9" creationId="{01D17A98-FF43-F22E-B344-AEF17D4683BE}"/>
-          </ac:spMkLst>
-        </pc:spChg>
         <pc:spChg chg="add mod ord">
           <ac:chgData name="McCloskey, Ross" userId="b1990487-ee44-4922-b58f-5b2980a02730" providerId="ADAL" clId="{7D443C21-FD7D-4E65-8C72-B41829F67170}" dt="2026-07-20T15:42:45.443" v="63" actId="20577"/>
           <ac:spMkLst>
@@ -226,22 +161,6 @@
           <pc:docMk/>
           <pc:sldMk cId="3855106060" sldId="257"/>
         </pc:sldMkLst>
-        <pc:spChg chg="del mod ord">
-          <ac:chgData name="McCloskey, Ross" userId="b1990487-ee44-4922-b58f-5b2980a02730" providerId="ADAL" clId="{7D443C21-FD7D-4E65-8C72-B41829F67170}" dt="2026-07-20T15:43:25.648" v="166" actId="700"/>
-          <ac:spMkLst>
-            <pc:docMk/>
-            <pc:sldMk cId="3855106060" sldId="257"/>
-            <ac:spMk id="2" creationId="{C816F4B7-EAA2-E92A-BB2C-ACE2538A8B63}"/>
-          </ac:spMkLst>
-        </pc:spChg>
-        <pc:spChg chg="del mod ord">
-          <ac:chgData name="McCloskey, Ross" userId="b1990487-ee44-4922-b58f-5b2980a02730" providerId="ADAL" clId="{7D443C21-FD7D-4E65-8C72-B41829F67170}" dt="2026-07-20T15:43:25.648" v="166" actId="700"/>
-          <ac:spMkLst>
-            <pc:docMk/>
-            <pc:sldMk cId="3855106060" sldId="257"/>
-            <ac:spMk id="3" creationId="{737B3F76-0442-C049-44A8-F4EF6C7857E4}"/>
-          </ac:spMkLst>
-        </pc:spChg>
         <pc:spChg chg="add mod ord">
           <ac:chgData name="McCloskey, Ross" userId="b1990487-ee44-4922-b58f-5b2980a02730" providerId="ADAL" clId="{7D443C21-FD7D-4E65-8C72-B41829F67170}" dt="2026-07-20T15:43:31.131" v="179" actId="20577"/>
           <ac:spMkLst>
@@ -265,22 +184,6 @@
           <pc:docMk/>
           <pc:sldMk cId="2678185482" sldId="258"/>
         </pc:sldMkLst>
-        <pc:spChg chg="del mod ord">
-          <ac:chgData name="McCloskey, Ross" userId="b1990487-ee44-4922-b58f-5b2980a02730" providerId="ADAL" clId="{7D443C21-FD7D-4E65-8C72-B41829F67170}" dt="2026-07-20T15:44:28.971" v="184" actId="700"/>
-          <ac:spMkLst>
-            <pc:docMk/>
-            <pc:sldMk cId="2678185482" sldId="258"/>
-            <ac:spMk id="2" creationId="{0853E192-7537-A4DF-3A2B-72BF6A5916B8}"/>
-          </ac:spMkLst>
-        </pc:spChg>
-        <pc:spChg chg="del">
-          <ac:chgData name="McCloskey, Ross" userId="b1990487-ee44-4922-b58f-5b2980a02730" providerId="ADAL" clId="{7D443C21-FD7D-4E65-8C72-B41829F67170}" dt="2026-07-20T15:44:28.971" v="184" actId="700"/>
-          <ac:spMkLst>
-            <pc:docMk/>
-            <pc:sldMk cId="2678185482" sldId="258"/>
-            <ac:spMk id="3" creationId="{96239110-BA96-8F28-CF02-BCD22519ACC5}"/>
-          </ac:spMkLst>
-        </pc:spChg>
         <pc:spChg chg="add mod ord">
           <ac:chgData name="McCloskey, Ross" userId="b1990487-ee44-4922-b58f-5b2980a02730" providerId="ADAL" clId="{7D443C21-FD7D-4E65-8C72-B41829F67170}" dt="2026-07-20T15:54:06.578" v="1063" actId="20577"/>
           <ac:spMkLst>
@@ -320,14 +223,6 @@
             <ac:picMk id="3" creationId="{9137BD2B-CCA5-A589-559E-B0961F839FEF}"/>
           </ac:picMkLst>
         </pc:picChg>
-        <pc:picChg chg="del">
-          <ac:chgData name="McCloskey, Ross" userId="b1990487-ee44-4922-b58f-5b2980a02730" providerId="ADAL" clId="{7D443C21-FD7D-4E65-8C72-B41829F67170}" dt="2026-07-20T15:49:44.358" v="566" actId="478"/>
-          <ac:picMkLst>
-            <pc:docMk/>
-            <pc:sldMk cId="577290267" sldId="259"/>
-            <ac:picMk id="6" creationId="{FF8847A7-EA10-12E7-5FDC-E156B4F10A3F}"/>
-          </ac:picMkLst>
-        </pc:picChg>
       </pc:sldChg>
       <pc:sldChg chg="delSp modSp new mod">
         <pc:chgData name="McCloskey, Ross" userId="b1990487-ee44-4922-b58f-5b2980a02730" providerId="ADAL" clId="{7D443C21-FD7D-4E65-8C72-B41829F67170}" dt="2026-07-20T15:53:39.252" v="1032" actId="478"/>
@@ -343,17 +238,9 @@
             <ac:spMk id="2" creationId="{390EDCA6-D3C7-70FE-0875-F42EDD39F4A9}"/>
           </ac:spMkLst>
         </pc:spChg>
-        <pc:spChg chg="del">
-          <ac:chgData name="McCloskey, Ross" userId="b1990487-ee44-4922-b58f-5b2980a02730" providerId="ADAL" clId="{7D443C21-FD7D-4E65-8C72-B41829F67170}" dt="2026-07-20T15:53:39.252" v="1032" actId="478"/>
-          <ac:spMkLst>
-            <pc:docMk/>
-            <pc:sldMk cId="3704713804" sldId="260"/>
-            <ac:spMk id="3" creationId="{836D34D2-2320-619A-8018-DF68AD4B08FA}"/>
-          </ac:spMkLst>
-        </pc:spChg>
       </pc:sldChg>
-      <pc:sldChg chg="delSp modSp add mod">
-        <pc:chgData name="McCloskey, Ross" userId="b1990487-ee44-4922-b58f-5b2980a02730" providerId="ADAL" clId="{7D443C21-FD7D-4E65-8C72-B41829F67170}" dt="2026-07-20T15:57:06.249" v="1256" actId="20577"/>
+      <pc:sldChg chg="addSp delSp modSp add mod">
+        <pc:chgData name="McCloskey, Ross" userId="b1990487-ee44-4922-b58f-5b2980a02730" providerId="ADAL" clId="{7D443C21-FD7D-4E65-8C72-B41829F67170}" dt="2026-08-05T18:55:51.991" v="3710" actId="166"/>
         <pc:sldMkLst>
           <pc:docMk/>
           <pc:sldMk cId="3258157237" sldId="261"/>
@@ -366,17 +253,49 @@
             <ac:spMk id="4" creationId="{4915F585-4BB4-5F27-9541-63B76984517E}"/>
           </ac:spMkLst>
         </pc:spChg>
-        <pc:picChg chg="del">
-          <ac:chgData name="McCloskey, Ross" userId="b1990487-ee44-4922-b58f-5b2980a02730" providerId="ADAL" clId="{7D443C21-FD7D-4E65-8C72-B41829F67170}" dt="2026-07-20T15:55:43.836" v="1083" actId="478"/>
+        <pc:picChg chg="add del mod modCrop">
+          <ac:chgData name="McCloskey, Ross" userId="b1990487-ee44-4922-b58f-5b2980a02730" providerId="ADAL" clId="{7D443C21-FD7D-4E65-8C72-B41829F67170}" dt="2026-08-05T18:45:39.149" v="3695" actId="478"/>
           <ac:picMkLst>
             <pc:docMk/>
             <pc:sldMk cId="3258157237" sldId="261"/>
-            <ac:picMk id="3" creationId="{9FA74CD2-4370-C23F-3AD9-E3252B658EC0}"/>
+            <ac:picMk id="3" creationId="{A6805772-4FFC-7BD2-F11F-54D0F2FF9302}"/>
+          </ac:picMkLst>
+        </pc:picChg>
+        <pc:picChg chg="add del mod">
+          <ac:chgData name="McCloskey, Ross" userId="b1990487-ee44-4922-b58f-5b2980a02730" providerId="ADAL" clId="{7D443C21-FD7D-4E65-8C72-B41829F67170}" dt="2026-08-05T18:54:12.219" v="3699" actId="478"/>
+          <ac:picMkLst>
+            <pc:docMk/>
+            <pc:sldMk cId="3258157237" sldId="261"/>
+            <ac:picMk id="6" creationId="{60481D3A-E6B5-0DC3-FC69-1D1950339449}"/>
+          </ac:picMkLst>
+        </pc:picChg>
+        <pc:picChg chg="add del mod">
+          <ac:chgData name="McCloskey, Ross" userId="b1990487-ee44-4922-b58f-5b2980a02730" providerId="ADAL" clId="{7D443C21-FD7D-4E65-8C72-B41829F67170}" dt="2026-08-05T18:55:08.499" v="3702" actId="478"/>
+          <ac:picMkLst>
+            <pc:docMk/>
+            <pc:sldMk cId="3258157237" sldId="261"/>
+            <ac:picMk id="8" creationId="{26BFD441-58BF-C6E7-E70E-9E6EC23528F2}"/>
+          </ac:picMkLst>
+        </pc:picChg>
+        <pc:picChg chg="add mod ord">
+          <ac:chgData name="McCloskey, Ross" userId="b1990487-ee44-4922-b58f-5b2980a02730" providerId="ADAL" clId="{7D443C21-FD7D-4E65-8C72-B41829F67170}" dt="2026-08-05T18:55:51.991" v="3710" actId="166"/>
+          <ac:picMkLst>
+            <pc:docMk/>
+            <pc:sldMk cId="3258157237" sldId="261"/>
+            <ac:picMk id="10" creationId="{9C6A8FAE-3197-53DB-081A-9F9B8B47FDB8}"/>
+          </ac:picMkLst>
+        </pc:picChg>
+        <pc:picChg chg="add mod">
+          <ac:chgData name="McCloskey, Ross" userId="b1990487-ee44-4922-b58f-5b2980a02730" providerId="ADAL" clId="{7D443C21-FD7D-4E65-8C72-B41829F67170}" dt="2026-08-05T18:55:47.011" v="3709" actId="1076"/>
+          <ac:picMkLst>
+            <pc:docMk/>
+            <pc:sldMk cId="3258157237" sldId="261"/>
+            <ac:picMk id="12" creationId="{75358480-967E-EB28-E15E-D655C65A741E}"/>
           </ac:picMkLst>
         </pc:picChg>
       </pc:sldChg>
-      <pc:sldChg chg="modSp add mod">
-        <pc:chgData name="McCloskey, Ross" userId="b1990487-ee44-4922-b58f-5b2980a02730" providerId="ADAL" clId="{7D443C21-FD7D-4E65-8C72-B41829F67170}" dt="2026-07-20T15:58:05.549" v="1338" actId="255"/>
+      <pc:sldChg chg="addSp delSp modSp add mod">
+        <pc:chgData name="McCloskey, Ross" userId="b1990487-ee44-4922-b58f-5b2980a02730" providerId="ADAL" clId="{7D443C21-FD7D-4E65-8C72-B41829F67170}" dt="2026-08-05T19:11:23.381" v="3722" actId="1076"/>
         <pc:sldMkLst>
           <pc:docMk/>
           <pc:sldMk cId="669740212" sldId="262"/>
@@ -389,16 +308,33 @@
             <ac:spMk id="4" creationId="{AFCAC89D-0816-F188-BFEB-DE08AFA05A8D}"/>
           </ac:spMkLst>
         </pc:spChg>
+        <pc:picChg chg="add del mod">
+          <ac:chgData name="McCloskey, Ross" userId="b1990487-ee44-4922-b58f-5b2980a02730" providerId="ADAL" clId="{7D443C21-FD7D-4E65-8C72-B41829F67170}" dt="2026-08-05T19:07:55.413" v="3715" actId="478"/>
+          <ac:picMkLst>
+            <pc:docMk/>
+            <pc:sldMk cId="669740212" sldId="262"/>
+            <ac:picMk id="3" creationId="{59A90D42-8F8C-66BA-AE1C-2921198341FC}"/>
+          </ac:picMkLst>
+        </pc:picChg>
+        <pc:picChg chg="add mod">
+          <ac:chgData name="McCloskey, Ross" userId="b1990487-ee44-4922-b58f-5b2980a02730" providerId="ADAL" clId="{7D443C21-FD7D-4E65-8C72-B41829F67170}" dt="2026-08-05T19:11:06.098" v="3719" actId="1076"/>
+          <ac:picMkLst>
+            <pc:docMk/>
+            <pc:sldMk cId="669740212" sldId="262"/>
+            <ac:picMk id="6" creationId="{4B26AA83-1CB4-189B-1A11-1A9E458DE720}"/>
+          </ac:picMkLst>
+        </pc:picChg>
+        <pc:picChg chg="add mod">
+          <ac:chgData name="McCloskey, Ross" userId="b1990487-ee44-4922-b58f-5b2980a02730" providerId="ADAL" clId="{7D443C21-FD7D-4E65-8C72-B41829F67170}" dt="2026-08-05T19:11:23.381" v="3722" actId="1076"/>
+          <ac:picMkLst>
+            <pc:docMk/>
+            <pc:sldMk cId="669740212" sldId="262"/>
+            <ac:picMk id="8" creationId="{FCDC7F1C-0850-D1F0-004B-C25FF84E6A24}"/>
+          </ac:picMkLst>
+        </pc:picChg>
       </pc:sldChg>
-      <pc:sldChg chg="new del">
-        <pc:chgData name="McCloskey, Ross" userId="b1990487-ee44-4922-b58f-5b2980a02730" providerId="ADAL" clId="{7D443C21-FD7D-4E65-8C72-B41829F67170}" dt="2026-07-20T15:58:51.771" v="1341" actId="47"/>
-        <pc:sldMkLst>
-          <pc:docMk/>
-          <pc:sldMk cId="258816084" sldId="263"/>
-        </pc:sldMkLst>
-      </pc:sldChg>
-      <pc:sldChg chg="modSp add mod">
-        <pc:chgData name="McCloskey, Ross" userId="b1990487-ee44-4922-b58f-5b2980a02730" providerId="ADAL" clId="{7D443C21-FD7D-4E65-8C72-B41829F67170}" dt="2026-07-20T16:03:25.794" v="1904" actId="20577"/>
+      <pc:sldChg chg="addSp modSp add mod">
+        <pc:chgData name="McCloskey, Ross" userId="b1990487-ee44-4922-b58f-5b2980a02730" providerId="ADAL" clId="{7D443C21-FD7D-4E65-8C72-B41829F67170}" dt="2026-08-05T18:19:09.090" v="3686" actId="255"/>
         <pc:sldMkLst>
           <pc:docMk/>
           <pc:sldMk cId="1660356394" sldId="263"/>
@@ -411,21 +347,37 @@
             <ac:spMk id="4" creationId="{648F083A-692A-C5EF-ED97-F63B76F80265}"/>
           </ac:spMkLst>
         </pc:spChg>
+        <pc:graphicFrameChg chg="add mod modGraphic">
+          <ac:chgData name="McCloskey, Ross" userId="b1990487-ee44-4922-b58f-5b2980a02730" providerId="ADAL" clId="{7D443C21-FD7D-4E65-8C72-B41829F67170}" dt="2026-08-05T18:19:09.090" v="3686" actId="255"/>
+          <ac:graphicFrameMkLst>
+            <pc:docMk/>
+            <pc:sldMk cId="1660356394" sldId="263"/>
+            <ac:graphicFrameMk id="2" creationId="{C8F4AD93-7124-DF47-70F0-EAFA46198C62}"/>
+          </ac:graphicFrameMkLst>
+        </pc:graphicFrameChg>
       </pc:sldChg>
-      <pc:sldChg chg="modSp add mod">
-        <pc:chgData name="McCloskey, Ross" userId="b1990487-ee44-4922-b58f-5b2980a02730" providerId="ADAL" clId="{7D443C21-FD7D-4E65-8C72-B41829F67170}" dt="2026-07-20T16:04:34.153" v="1984" actId="1076"/>
+      <pc:sldChg chg="addSp modSp add mod">
+        <pc:chgData name="McCloskey, Ross" userId="b1990487-ee44-4922-b58f-5b2980a02730" providerId="ADAL" clId="{7D443C21-FD7D-4E65-8C72-B41829F67170}" dt="2026-08-05T18:18:52.750" v="3685" actId="1076"/>
         <pc:sldMkLst>
           <pc:docMk/>
           <pc:sldMk cId="646512240" sldId="264"/>
         </pc:sldMkLst>
         <pc:spChg chg="mod">
-          <ac:chgData name="McCloskey, Ross" userId="b1990487-ee44-4922-b58f-5b2980a02730" providerId="ADAL" clId="{7D443C21-FD7D-4E65-8C72-B41829F67170}" dt="2026-07-20T16:04:34.153" v="1984" actId="1076"/>
+          <ac:chgData name="McCloskey, Ross" userId="b1990487-ee44-4922-b58f-5b2980a02730" providerId="ADAL" clId="{7D443C21-FD7D-4E65-8C72-B41829F67170}" dt="2026-08-05T18:18:42.024" v="3684" actId="1076"/>
           <ac:spMkLst>
             <pc:docMk/>
             <pc:sldMk cId="646512240" sldId="264"/>
             <ac:spMk id="4" creationId="{C2166C8B-63A5-630A-051D-AED281BA7F24}"/>
           </ac:spMkLst>
         </pc:spChg>
+        <pc:graphicFrameChg chg="add mod modGraphic">
+          <ac:chgData name="McCloskey, Ross" userId="b1990487-ee44-4922-b58f-5b2980a02730" providerId="ADAL" clId="{7D443C21-FD7D-4E65-8C72-B41829F67170}" dt="2026-08-05T18:18:52.750" v="3685" actId="1076"/>
+          <ac:graphicFrameMkLst>
+            <pc:docMk/>
+            <pc:sldMk cId="646512240" sldId="264"/>
+            <ac:graphicFrameMk id="3" creationId="{30DB109B-E96C-1C40-5475-7D086EA7FA15}"/>
+          </ac:graphicFrameMkLst>
+        </pc:graphicFrameChg>
       </pc:sldChg>
       <pc:sldChg chg="addSp delSp modSp add mod ord">
         <pc:chgData name="McCloskey, Ross" userId="b1990487-ee44-4922-b58f-5b2980a02730" providerId="ADAL" clId="{7D443C21-FD7D-4E65-8C72-B41829F67170}" dt="2026-07-20T16:09:41.479" v="2457" actId="1076"/>
@@ -441,14 +393,6 @@
             <ac:spMk id="4" creationId="{F1810874-F6CD-271A-95D0-412424B52466}"/>
           </ac:spMkLst>
         </pc:spChg>
-        <pc:picChg chg="add del mod">
-          <ac:chgData name="McCloskey, Ross" userId="b1990487-ee44-4922-b58f-5b2980a02730" providerId="ADAL" clId="{7D443C21-FD7D-4E65-8C72-B41829F67170}" dt="2026-07-20T16:09:21.473" v="2454" actId="478"/>
-          <ac:picMkLst>
-            <pc:docMk/>
-            <pc:sldMk cId="3392081390" sldId="265"/>
-            <ac:picMk id="3" creationId="{50B7F7C3-12FB-5715-DD98-A6E0098064E9}"/>
-          </ac:picMkLst>
-        </pc:picChg>
         <pc:picChg chg="add mod">
           <ac:chgData name="McCloskey, Ross" userId="b1990487-ee44-4922-b58f-5b2980a02730" providerId="ADAL" clId="{7D443C21-FD7D-4E65-8C72-B41829F67170}" dt="2026-07-20T16:09:41.479" v="2457" actId="1076"/>
           <ac:picMkLst>
@@ -457,6 +401,59 @@
             <ac:picMk id="6" creationId="{946A4565-A6A7-3A5C-1C1C-69D7C68A2EB1}"/>
           </ac:picMkLst>
         </pc:picChg>
+      </pc:sldChg>
+      <pc:sldChg chg="modSp add mod">
+        <pc:chgData name="McCloskey, Ross" userId="b1990487-ee44-4922-b58f-5b2980a02730" providerId="ADAL" clId="{7D443C21-FD7D-4E65-8C72-B41829F67170}" dt="2026-08-05T17:35:22.724" v="2580" actId="20577"/>
+        <pc:sldMkLst>
+          <pc:docMk/>
+          <pc:sldMk cId="4010563470" sldId="266"/>
+        </pc:sldMkLst>
+        <pc:spChg chg="mod">
+          <ac:chgData name="McCloskey, Ross" userId="b1990487-ee44-4922-b58f-5b2980a02730" providerId="ADAL" clId="{7D443C21-FD7D-4E65-8C72-B41829F67170}" dt="2026-08-05T17:34:39.944" v="2461" actId="20577"/>
+          <ac:spMkLst>
+            <pc:docMk/>
+            <pc:sldMk cId="4010563470" sldId="266"/>
+            <ac:spMk id="4" creationId="{EED71206-5DEB-59B9-58B9-E3E8535388C6}"/>
+          </ac:spMkLst>
+        </pc:spChg>
+        <pc:spChg chg="mod">
+          <ac:chgData name="McCloskey, Ross" userId="b1990487-ee44-4922-b58f-5b2980a02730" providerId="ADAL" clId="{7D443C21-FD7D-4E65-8C72-B41829F67170}" dt="2026-08-05T17:35:22.724" v="2580" actId="20577"/>
+          <ac:spMkLst>
+            <pc:docMk/>
+            <pc:sldMk cId="4010563470" sldId="266"/>
+            <ac:spMk id="5" creationId="{6D82CA60-3EAB-EE79-1D86-2021B3B5417A}"/>
+          </ac:spMkLst>
+        </pc:spChg>
+      </pc:sldChg>
+      <pc:sldChg chg="modSp add mod">
+        <pc:chgData name="McCloskey, Ross" userId="b1990487-ee44-4922-b58f-5b2980a02730" providerId="ADAL" clId="{7D443C21-FD7D-4E65-8C72-B41829F67170}" dt="2026-08-05T17:36:29.443" v="2679" actId="20577"/>
+        <pc:sldMkLst>
+          <pc:docMk/>
+          <pc:sldMk cId="2827154758" sldId="267"/>
+        </pc:sldMkLst>
+        <pc:spChg chg="mod">
+          <ac:chgData name="McCloskey, Ross" userId="b1990487-ee44-4922-b58f-5b2980a02730" providerId="ADAL" clId="{7D443C21-FD7D-4E65-8C72-B41829F67170}" dt="2026-08-05T17:34:44.497" v="2463" actId="20577"/>
+          <ac:spMkLst>
+            <pc:docMk/>
+            <pc:sldMk cId="2827154758" sldId="267"/>
+            <ac:spMk id="4" creationId="{DD50304E-E4A7-EF2C-3D5C-CB8F9AA1E942}"/>
+          </ac:spMkLst>
+        </pc:spChg>
+        <pc:spChg chg="mod">
+          <ac:chgData name="McCloskey, Ross" userId="b1990487-ee44-4922-b58f-5b2980a02730" providerId="ADAL" clId="{7D443C21-FD7D-4E65-8C72-B41829F67170}" dt="2026-08-05T17:36:29.443" v="2679" actId="20577"/>
+          <ac:spMkLst>
+            <pc:docMk/>
+            <pc:sldMk cId="2827154758" sldId="267"/>
+            <ac:spMk id="5" creationId="{96598701-C0E7-8830-851B-70B89A3BCD13}"/>
+          </ac:spMkLst>
+        </pc:spChg>
+      </pc:sldChg>
+      <pc:sldChg chg="new del">
+        <pc:chgData name="McCloskey, Ross" userId="b1990487-ee44-4922-b58f-5b2980a02730" providerId="ADAL" clId="{7D443C21-FD7D-4E65-8C72-B41829F67170}" dt="2026-08-05T19:56:16.129" v="3723" actId="47"/>
+        <pc:sldMkLst>
+          <pc:docMk/>
+          <pc:sldMk cId="1891765391" sldId="268"/>
+        </pc:sldMkLst>
       </pc:sldChg>
     </pc:docChg>
   </pc:docChgLst>
@@ -610,7 +607,7 @@
           <a:p>
             <a:fld id="{736DCF12-0259-4C62-9CAA-1EF9D21CC0D2}" type="datetimeFigureOut">
               <a:rPr lang="en-US" smtClean="0"/>
-              <a:t>7/20/2026</a:t>
+              <a:t>8/5/2026</a:t>
             </a:fld>
             <a:endParaRPr lang="en-US"/>
           </a:p>
@@ -808,7 +805,7 @@
           <a:p>
             <a:fld id="{736DCF12-0259-4C62-9CAA-1EF9D21CC0D2}" type="datetimeFigureOut">
               <a:rPr lang="en-US" smtClean="0"/>
-              <a:t>7/20/2026</a:t>
+              <a:t>8/5/2026</a:t>
             </a:fld>
             <a:endParaRPr lang="en-US"/>
           </a:p>
@@ -1016,7 +1013,7 @@
           <a:p>
             <a:fld id="{736DCF12-0259-4C62-9CAA-1EF9D21CC0D2}" type="datetimeFigureOut">
               <a:rPr lang="en-US" smtClean="0"/>
-              <a:t>7/20/2026</a:t>
+              <a:t>8/5/2026</a:t>
             </a:fld>
             <a:endParaRPr lang="en-US"/>
           </a:p>
@@ -1214,7 +1211,7 @@
           <a:p>
             <a:fld id="{736DCF12-0259-4C62-9CAA-1EF9D21CC0D2}" type="datetimeFigureOut">
               <a:rPr lang="en-US" smtClean="0"/>
-              <a:t>7/20/2026</a:t>
+              <a:t>8/5/2026</a:t>
             </a:fld>
             <a:endParaRPr lang="en-US"/>
           </a:p>
@@ -1489,7 +1486,7 @@
           <a:p>
             <a:fld id="{736DCF12-0259-4C62-9CAA-1EF9D21CC0D2}" type="datetimeFigureOut">
               <a:rPr lang="en-US" smtClean="0"/>
-              <a:t>7/20/2026</a:t>
+              <a:t>8/5/2026</a:t>
             </a:fld>
             <a:endParaRPr lang="en-US"/>
           </a:p>
@@ -1754,7 +1751,7 @@
           <a:p>
             <a:fld id="{736DCF12-0259-4C62-9CAA-1EF9D21CC0D2}" type="datetimeFigureOut">
               <a:rPr lang="en-US" smtClean="0"/>
-              <a:t>7/20/2026</a:t>
+              <a:t>8/5/2026</a:t>
             </a:fld>
             <a:endParaRPr lang="en-US"/>
           </a:p>
@@ -2166,7 +2163,7 @@
           <a:p>
             <a:fld id="{736DCF12-0259-4C62-9CAA-1EF9D21CC0D2}" type="datetimeFigureOut">
               <a:rPr lang="en-US" smtClean="0"/>
-              <a:t>7/20/2026</a:t>
+              <a:t>8/5/2026</a:t>
             </a:fld>
             <a:endParaRPr lang="en-US"/>
           </a:p>
@@ -2307,7 +2304,7 @@
           <a:p>
             <a:fld id="{736DCF12-0259-4C62-9CAA-1EF9D21CC0D2}" type="datetimeFigureOut">
               <a:rPr lang="en-US" smtClean="0"/>
-              <a:t>7/20/2026</a:t>
+              <a:t>8/5/2026</a:t>
             </a:fld>
             <a:endParaRPr lang="en-US"/>
           </a:p>
@@ -2420,7 +2417,7 @@
           <a:p>
             <a:fld id="{736DCF12-0259-4C62-9CAA-1EF9D21CC0D2}" type="datetimeFigureOut">
               <a:rPr lang="en-US" smtClean="0"/>
-              <a:t>7/20/2026</a:t>
+              <a:t>8/5/2026</a:t>
             </a:fld>
             <a:endParaRPr lang="en-US"/>
           </a:p>
@@ -2731,7 +2728,7 @@
           <a:p>
             <a:fld id="{736DCF12-0259-4C62-9CAA-1EF9D21CC0D2}" type="datetimeFigureOut">
               <a:rPr lang="en-US" smtClean="0"/>
-              <a:t>7/20/2026</a:t>
+              <a:t>8/5/2026</a:t>
             </a:fld>
             <a:endParaRPr lang="en-US"/>
           </a:p>
@@ -3019,7 +3016,7 @@
           <a:p>
             <a:fld id="{736DCF12-0259-4C62-9CAA-1EF9D21CC0D2}" type="datetimeFigureOut">
               <a:rPr lang="en-US" smtClean="0"/>
-              <a:t>7/20/2026</a:t>
+              <a:t>8/5/2026</a:t>
             </a:fld>
             <a:endParaRPr lang="en-US"/>
           </a:p>
@@ -3260,7 +3257,7 @@
           <a:p>
             <a:fld id="{736DCF12-0259-4C62-9CAA-1EF9D21CC0D2}" type="datetimeFigureOut">
               <a:rPr lang="en-US" smtClean="0"/>
-              <a:t>7/20/2026</a:t>
+              <a:t>8/5/2026</a:t>
             </a:fld>
             <a:endParaRPr lang="en-US"/>
           </a:p>
@@ -3754,6 +3751,1420 @@
         <p:cNvPr id="1" name="">
           <a:extLst>
             <a:ext uri="{FF2B5EF4-FFF2-40B4-BE49-F238E27FC236}">
+              <a16:creationId xmlns:a16="http://schemas.microsoft.com/office/drawing/2014/main" id="{FFD4A439-88E8-8DB4-11B1-CBEAB3CB71D2}"/>
+            </a:ext>
+          </a:extLst>
+        </p:cNvPr>
+        <p:cNvGrpSpPr/>
+        <p:nvPr/>
+      </p:nvGrpSpPr>
+      <p:grpSpPr>
+        <a:xfrm>
+          <a:off x="0" y="0"/>
+          <a:ext cx="0" cy="0"/>
+          <a:chOff x="0" y="0"/>
+          <a:chExt cx="0" cy="0"/>
+        </a:xfrm>
+      </p:grpSpPr>
+      <p:sp>
+        <p:nvSpPr>
+          <p:cNvPr id="4" name="Title 3">
+            <a:extLst>
+              <a:ext uri="{FF2B5EF4-FFF2-40B4-BE49-F238E27FC236}">
+                <a16:creationId xmlns:a16="http://schemas.microsoft.com/office/drawing/2014/main" id="{648F083A-692A-C5EF-ED97-F63B76F80265}"/>
+              </a:ext>
+            </a:extLst>
+          </p:cNvPr>
+          <p:cNvSpPr>
+            <a:spLocks noGrp="1"/>
+          </p:cNvSpPr>
+          <p:nvPr>
+            <p:ph type="title"/>
+          </p:nvPr>
+        </p:nvSpPr>
+        <p:spPr>
+          <a:xfrm>
+            <a:off x="838200" y="206439"/>
+            <a:ext cx="10515600" cy="759339"/>
+          </a:xfrm>
+        </p:spPr>
+        <p:txBody>
+          <a:bodyPr>
+            <a:noAutofit/>
+          </a:bodyPr>
+          <a:lstStyle/>
+          <a:p>
+            <a:r>
+              <a:rPr lang="en-US" sz="2000" i="1" dirty="0"/>
+              <a:t>Supplemental Table 1</a:t>
+            </a:r>
+            <a:r>
+              <a:rPr lang="en-US" sz="2000" dirty="0"/>
+              <a:t>: Results of indicator species analysis (ISA) on net tows clustered by AHC. Max number of clusters that can be indicated together set equal to two. Used to verify the dominant taxa for each cluster and the use of clusters as representatives of taxa assemblages.</a:t>
+            </a:r>
+            <a:endParaRPr lang="en-US" sz="2000" i="1" dirty="0"/>
+          </a:p>
+        </p:txBody>
+      </p:sp>
+      <p:graphicFrame>
+        <p:nvGraphicFramePr>
+          <p:cNvPr id="2" name="Table 1">
+            <a:extLst>
+              <a:ext uri="{FF2B5EF4-FFF2-40B4-BE49-F238E27FC236}">
+                <a16:creationId xmlns:a16="http://schemas.microsoft.com/office/drawing/2014/main" id="{C8F4AD93-7124-DF47-70F0-EAFA46198C62}"/>
+              </a:ext>
+            </a:extLst>
+          </p:cNvPr>
+          <p:cNvGraphicFramePr>
+            <a:graphicFrameLocks noGrp="1"/>
+          </p:cNvGraphicFramePr>
+          <p:nvPr>
+            <p:extLst>
+              <p:ext uri="{D42A27DB-BD31-4B8C-83A1-F6EECF244321}">
+                <p14:modId xmlns:p14="http://schemas.microsoft.com/office/powerpoint/2010/main" val="3630301574"/>
+              </p:ext>
+            </p:extLst>
+          </p:nvPr>
+        </p:nvGraphicFramePr>
+        <p:xfrm>
+          <a:off x="2032000" y="1671136"/>
+          <a:ext cx="8127999" cy="4160520"/>
+        </p:xfrm>
+        <a:graphic>
+          <a:graphicData uri="http://schemas.openxmlformats.org/drawingml/2006/table">
+            <a:tbl>
+              <a:tblPr firstRow="1" bandRow="1">
+                <a:tableStyleId>{5940675A-B579-460E-94D1-54222C63F5DA}</a:tableStyleId>
+              </a:tblPr>
+              <a:tblGrid>
+                <a:gridCol w="1390822">
+                  <a:extLst>
+                    <a:ext uri="{9D8B030D-6E8A-4147-A177-3AD203B41FA5}">
+                      <a16:colId xmlns:a16="http://schemas.microsoft.com/office/drawing/2014/main" val="3288010381"/>
+                    </a:ext>
+                  </a:extLst>
+                </a:gridCol>
+                <a:gridCol w="4027844">
+                  <a:extLst>
+                    <a:ext uri="{9D8B030D-6E8A-4147-A177-3AD203B41FA5}">
+                      <a16:colId xmlns:a16="http://schemas.microsoft.com/office/drawing/2014/main" val="238683654"/>
+                    </a:ext>
+                  </a:extLst>
+                </a:gridCol>
+                <a:gridCol w="2709333">
+                  <a:extLst>
+                    <a:ext uri="{9D8B030D-6E8A-4147-A177-3AD203B41FA5}">
+                      <a16:colId xmlns:a16="http://schemas.microsoft.com/office/drawing/2014/main" val="2418419917"/>
+                    </a:ext>
+                  </a:extLst>
+                </a:gridCol>
+              </a:tblGrid>
+              <a:tr h="370840">
+                <a:tc>
+                  <a:txBody>
+                    <a:bodyPr/>
+                    <a:lstStyle/>
+                    <a:p>
+                      <a:r>
+                        <a:rPr lang="en-US" sz="1600" dirty="0"/>
+                        <a:t>Cluster(s)</a:t>
+                      </a:r>
+                    </a:p>
+                  </a:txBody>
+                  <a:tcPr/>
+                </a:tc>
+                <a:tc>
+                  <a:txBody>
+                    <a:bodyPr/>
+                    <a:lstStyle/>
+                    <a:p>
+                      <a:r>
+                        <a:rPr lang="en-US" sz="1600" dirty="0"/>
+                        <a:t>Taxa</a:t>
+                      </a:r>
+                    </a:p>
+                  </a:txBody>
+                  <a:tcPr/>
+                </a:tc>
+                <a:tc>
+                  <a:txBody>
+                    <a:bodyPr/>
+                    <a:lstStyle/>
+                    <a:p>
+                      <a:r>
+                        <a:rPr lang="en-US" sz="1600" dirty="0"/>
+                        <a:t>P-value</a:t>
+                      </a:r>
+                    </a:p>
+                  </a:txBody>
+                  <a:tcPr/>
+                </a:tc>
+                <a:extLst>
+                  <a:ext uri="{0D108BD9-81ED-4DB2-BD59-A6C34878D82A}">
+                    <a16:rowId xmlns:a16="http://schemas.microsoft.com/office/drawing/2014/main" val="3621098174"/>
+                  </a:ext>
+                </a:extLst>
+              </a:tr>
+              <a:tr h="370840">
+                <a:tc>
+                  <a:txBody>
+                    <a:bodyPr/>
+                    <a:lstStyle/>
+                    <a:p>
+                      <a:r>
+                        <a:rPr lang="en-US" sz="1600" dirty="0"/>
+                        <a:t>10</a:t>
+                      </a:r>
+                    </a:p>
+                  </a:txBody>
+                  <a:tcPr/>
+                </a:tc>
+                <a:tc>
+                  <a:txBody>
+                    <a:bodyPr/>
+                    <a:lstStyle/>
+                    <a:p>
+                      <a:r>
+                        <a:rPr lang="en-US" sz="1600" dirty="0" err="1"/>
+                        <a:t>Hexagrammidae</a:t>
+                      </a:r>
+                      <a:endParaRPr lang="en-US" sz="1600" dirty="0"/>
+                    </a:p>
+                  </a:txBody>
+                  <a:tcPr/>
+                </a:tc>
+                <a:tc>
+                  <a:txBody>
+                    <a:bodyPr/>
+                    <a:lstStyle/>
+                    <a:p>
+                      <a:r>
+                        <a:rPr lang="en-US" sz="1600" dirty="0"/>
+                        <a:t>0.005 **</a:t>
+                      </a:r>
+                    </a:p>
+                  </a:txBody>
+                  <a:tcPr/>
+                </a:tc>
+                <a:extLst>
+                  <a:ext uri="{0D108BD9-81ED-4DB2-BD59-A6C34878D82A}">
+                    <a16:rowId xmlns:a16="http://schemas.microsoft.com/office/drawing/2014/main" val="3145787672"/>
+                  </a:ext>
+                </a:extLst>
+              </a:tr>
+              <a:tr h="370840">
+                <a:tc>
+                  <a:txBody>
+                    <a:bodyPr/>
+                    <a:lstStyle/>
+                    <a:p>
+                      <a:r>
+                        <a:rPr lang="en-US" sz="1600" dirty="0"/>
+                        <a:t>1 + 5</a:t>
+                      </a:r>
+                    </a:p>
+                  </a:txBody>
+                  <a:tcPr/>
+                </a:tc>
+                <a:tc>
+                  <a:txBody>
+                    <a:bodyPr/>
+                    <a:lstStyle/>
+                    <a:p>
+                      <a:r>
+                        <a:rPr lang="en-US" sz="1600" i="1" dirty="0"/>
+                        <a:t>Sebastes</a:t>
+                      </a:r>
+                      <a:r>
+                        <a:rPr lang="en-US" sz="1600" i="0" dirty="0"/>
+                        <a:t> spp.</a:t>
+                      </a:r>
+                      <a:endParaRPr lang="en-US" sz="1600" i="1" dirty="0"/>
+                    </a:p>
+                  </a:txBody>
+                  <a:tcPr/>
+                </a:tc>
+                <a:tc>
+                  <a:txBody>
+                    <a:bodyPr/>
+                    <a:lstStyle/>
+                    <a:p>
+                      <a:r>
+                        <a:rPr lang="en-US" sz="1600" dirty="0"/>
+                        <a:t>0.005 **</a:t>
+                      </a:r>
+                    </a:p>
+                  </a:txBody>
+                  <a:tcPr/>
+                </a:tc>
+                <a:extLst>
+                  <a:ext uri="{0D108BD9-81ED-4DB2-BD59-A6C34878D82A}">
+                    <a16:rowId xmlns:a16="http://schemas.microsoft.com/office/drawing/2014/main" val="1892644640"/>
+                  </a:ext>
+                </a:extLst>
+              </a:tr>
+              <a:tr h="370840">
+                <a:tc>
+                  <a:txBody>
+                    <a:bodyPr/>
+                    <a:lstStyle/>
+                    <a:p>
+                      <a:r>
+                        <a:rPr lang="en-US" sz="1600" dirty="0"/>
+                        <a:t>2 + 6</a:t>
+                      </a:r>
+                    </a:p>
+                  </a:txBody>
+                  <a:tcPr/>
+                </a:tc>
+                <a:tc>
+                  <a:txBody>
+                    <a:bodyPr/>
+                    <a:lstStyle/>
+                    <a:p>
+                      <a:r>
+                        <a:rPr lang="en-US" sz="1600" i="1" dirty="0" err="1"/>
+                        <a:t>Parophrys</a:t>
+                      </a:r>
+                      <a:r>
+                        <a:rPr lang="en-US" sz="1600" i="1" dirty="0"/>
+                        <a:t> </a:t>
+                      </a:r>
+                      <a:r>
+                        <a:rPr lang="en-US" sz="1600" i="1" dirty="0" err="1"/>
+                        <a:t>vetulus</a:t>
+                      </a:r>
+                      <a:endParaRPr lang="en-US" sz="1600" i="1" dirty="0"/>
+                    </a:p>
+                  </a:txBody>
+                  <a:tcPr/>
+                </a:tc>
+                <a:tc>
+                  <a:txBody>
+                    <a:bodyPr/>
+                    <a:lstStyle/>
+                    <a:p>
+                      <a:r>
+                        <a:rPr lang="en-US" sz="1600" dirty="0"/>
+                        <a:t>0.005 **</a:t>
+                      </a:r>
+                    </a:p>
+                  </a:txBody>
+                  <a:tcPr/>
+                </a:tc>
+                <a:extLst>
+                  <a:ext uri="{0D108BD9-81ED-4DB2-BD59-A6C34878D82A}">
+                    <a16:rowId xmlns:a16="http://schemas.microsoft.com/office/drawing/2014/main" val="2227666454"/>
+                  </a:ext>
+                </a:extLst>
+              </a:tr>
+              <a:tr h="370840">
+                <a:tc>
+                  <a:txBody>
+                    <a:bodyPr/>
+                    <a:lstStyle/>
+                    <a:p>
+                      <a:r>
+                        <a:rPr lang="en-US" sz="1600" dirty="0"/>
+                        <a:t>3 + 4</a:t>
+                      </a:r>
+                    </a:p>
+                  </a:txBody>
+                  <a:tcPr/>
+                </a:tc>
+                <a:tc>
+                  <a:txBody>
+                    <a:bodyPr/>
+                    <a:lstStyle/>
+                    <a:p>
+                      <a:r>
+                        <a:rPr lang="en-US" sz="1600" i="1" dirty="0" err="1"/>
+                        <a:t>Bathylagus</a:t>
+                      </a:r>
+                      <a:r>
+                        <a:rPr lang="en-US" sz="1600" i="1" dirty="0"/>
+                        <a:t> </a:t>
+                      </a:r>
+                      <a:r>
+                        <a:rPr lang="en-US" sz="1600" i="1" dirty="0" err="1"/>
+                        <a:t>ochotensis</a:t>
+                      </a:r>
+                      <a:endParaRPr lang="en-US" sz="1600" i="1" dirty="0"/>
+                    </a:p>
+                  </a:txBody>
+                  <a:tcPr/>
+                </a:tc>
+                <a:tc>
+                  <a:txBody>
+                    <a:bodyPr/>
+                    <a:lstStyle/>
+                    <a:p>
+                      <a:r>
+                        <a:rPr lang="en-US" sz="1600" dirty="0"/>
+                        <a:t>0.025 *</a:t>
+                      </a:r>
+                    </a:p>
+                  </a:txBody>
+                  <a:tcPr/>
+                </a:tc>
+                <a:extLst>
+                  <a:ext uri="{0D108BD9-81ED-4DB2-BD59-A6C34878D82A}">
+                    <a16:rowId xmlns:a16="http://schemas.microsoft.com/office/drawing/2014/main" val="3253798277"/>
+                  </a:ext>
+                </a:extLst>
+              </a:tr>
+              <a:tr h="370840">
+                <a:tc>
+                  <a:txBody>
+                    <a:bodyPr/>
+                    <a:lstStyle/>
+                    <a:p>
+                      <a:r>
+                        <a:rPr lang="en-US" sz="1600" dirty="0"/>
+                        <a:t>4 + 10</a:t>
+                      </a:r>
+                    </a:p>
+                  </a:txBody>
+                  <a:tcPr/>
+                </a:tc>
+                <a:tc>
+                  <a:txBody>
+                    <a:bodyPr/>
+                    <a:lstStyle/>
+                    <a:p>
+                      <a:r>
+                        <a:rPr lang="en-US" sz="1600" i="1" dirty="0" err="1"/>
+                        <a:t>Stenobrachius</a:t>
+                      </a:r>
+                      <a:r>
+                        <a:rPr lang="en-US" sz="1600" i="1" dirty="0"/>
+                        <a:t> </a:t>
+                      </a:r>
+                      <a:r>
+                        <a:rPr lang="en-US" sz="1600" i="1" dirty="0" err="1"/>
+                        <a:t>leucopsarus</a:t>
+                      </a:r>
+                      <a:endParaRPr lang="en-US" sz="1600" i="1" dirty="0"/>
+                    </a:p>
+                  </a:txBody>
+                  <a:tcPr/>
+                </a:tc>
+                <a:tc>
+                  <a:txBody>
+                    <a:bodyPr/>
+                    <a:lstStyle/>
+                    <a:p>
+                      <a:r>
+                        <a:rPr lang="en-US" sz="1600" dirty="0"/>
+                        <a:t>0.01 **</a:t>
+                      </a:r>
+                    </a:p>
+                  </a:txBody>
+                  <a:tcPr/>
+                </a:tc>
+                <a:extLst>
+                  <a:ext uri="{0D108BD9-81ED-4DB2-BD59-A6C34878D82A}">
+                    <a16:rowId xmlns:a16="http://schemas.microsoft.com/office/drawing/2014/main" val="2364807414"/>
+                  </a:ext>
+                </a:extLst>
+              </a:tr>
+              <a:tr h="370840">
+                <a:tc>
+                  <a:txBody>
+                    <a:bodyPr/>
+                    <a:lstStyle/>
+                    <a:p>
+                      <a:r>
+                        <a:rPr lang="en-US" sz="1600" dirty="0"/>
+                        <a:t>5 + 6</a:t>
+                      </a:r>
+                    </a:p>
+                  </a:txBody>
+                  <a:tcPr/>
+                </a:tc>
+                <a:tc>
+                  <a:txBody>
+                    <a:bodyPr/>
+                    <a:lstStyle/>
+                    <a:p>
+                      <a:r>
+                        <a:rPr lang="en-US" sz="1600" i="1" dirty="0" err="1"/>
+                        <a:t>Isopsetta</a:t>
+                      </a:r>
+                      <a:r>
+                        <a:rPr lang="en-US" sz="1600" i="1" dirty="0"/>
+                        <a:t> </a:t>
+                      </a:r>
+                      <a:r>
+                        <a:rPr lang="en-US" sz="1600" i="1" dirty="0" err="1"/>
+                        <a:t>isolepis</a:t>
+                      </a:r>
+                      <a:endParaRPr lang="en-US" sz="1600" i="1" dirty="0"/>
+                    </a:p>
+                  </a:txBody>
+                  <a:tcPr/>
+                </a:tc>
+                <a:tc>
+                  <a:txBody>
+                    <a:bodyPr/>
+                    <a:lstStyle/>
+                    <a:p>
+                      <a:r>
+                        <a:rPr lang="en-US" sz="1600" dirty="0"/>
+                        <a:t>0.02 *</a:t>
+                      </a:r>
+                    </a:p>
+                  </a:txBody>
+                  <a:tcPr/>
+                </a:tc>
+                <a:extLst>
+                  <a:ext uri="{0D108BD9-81ED-4DB2-BD59-A6C34878D82A}">
+                    <a16:rowId xmlns:a16="http://schemas.microsoft.com/office/drawing/2014/main" val="4229098351"/>
+                  </a:ext>
+                </a:extLst>
+              </a:tr>
+              <a:tr h="370840">
+                <a:tc>
+                  <a:txBody>
+                    <a:bodyPr/>
+                    <a:lstStyle/>
+                    <a:p>
+                      <a:r>
+                        <a:rPr lang="en-US" sz="1600" dirty="0"/>
+                        <a:t>5 + 10</a:t>
+                      </a:r>
+                    </a:p>
+                  </a:txBody>
+                  <a:tcPr/>
+                </a:tc>
+                <a:tc>
+                  <a:txBody>
+                    <a:bodyPr/>
+                    <a:lstStyle/>
+                    <a:p>
+                      <a:r>
+                        <a:rPr lang="en-US" sz="1600" i="1" dirty="0"/>
+                        <a:t>Liparis</a:t>
+                      </a:r>
+                      <a:r>
+                        <a:rPr lang="en-US" sz="1600" i="0" dirty="0"/>
+                        <a:t> spp.</a:t>
+                      </a:r>
+                      <a:endParaRPr lang="en-US" sz="1600" i="1" dirty="0"/>
+                    </a:p>
+                  </a:txBody>
+                  <a:tcPr/>
+                </a:tc>
+                <a:tc>
+                  <a:txBody>
+                    <a:bodyPr/>
+                    <a:lstStyle/>
+                    <a:p>
+                      <a:r>
+                        <a:rPr lang="en-US" sz="1600" dirty="0"/>
+                        <a:t>0.005 **</a:t>
+                      </a:r>
+                    </a:p>
+                  </a:txBody>
+                  <a:tcPr/>
+                </a:tc>
+                <a:extLst>
+                  <a:ext uri="{0D108BD9-81ED-4DB2-BD59-A6C34878D82A}">
+                    <a16:rowId xmlns:a16="http://schemas.microsoft.com/office/drawing/2014/main" val="1711312673"/>
+                  </a:ext>
+                </a:extLst>
+              </a:tr>
+              <a:tr h="370840">
+                <a:tc>
+                  <a:txBody>
+                    <a:bodyPr/>
+                    <a:lstStyle/>
+                    <a:p>
+                      <a:r>
+                        <a:rPr lang="en-US" sz="1600" dirty="0"/>
+                        <a:t>6 + 9</a:t>
+                      </a:r>
+                    </a:p>
+                  </a:txBody>
+                  <a:tcPr/>
+                </a:tc>
+                <a:tc>
+                  <a:txBody>
+                    <a:bodyPr/>
+                    <a:lstStyle/>
+                    <a:p>
+                      <a:r>
+                        <a:rPr lang="en-US" sz="1600" dirty="0"/>
+                        <a:t>Osmeridae</a:t>
+                      </a:r>
+                    </a:p>
+                    <a:p>
+                      <a:r>
+                        <a:rPr lang="en-US" sz="1600" i="1" dirty="0" err="1"/>
+                        <a:t>Psettichthys</a:t>
+                      </a:r>
+                      <a:r>
+                        <a:rPr lang="en-US" sz="1600" i="1" dirty="0"/>
+                        <a:t> </a:t>
+                      </a:r>
+                      <a:r>
+                        <a:rPr lang="en-US" sz="1600" i="1" dirty="0" err="1"/>
+                        <a:t>melanostictus</a:t>
+                      </a:r>
+                      <a:endParaRPr lang="en-US" sz="1600" i="0" dirty="0"/>
+                    </a:p>
+                    <a:p>
+                      <a:r>
+                        <a:rPr lang="en-US" sz="1600" i="0" dirty="0" err="1"/>
+                        <a:t>Gadidae</a:t>
+                      </a:r>
+                      <a:endParaRPr lang="en-US" sz="1600" i="1" dirty="0"/>
+                    </a:p>
+                  </a:txBody>
+                  <a:tcPr/>
+                </a:tc>
+                <a:tc>
+                  <a:txBody>
+                    <a:bodyPr/>
+                    <a:lstStyle/>
+                    <a:p>
+                      <a:r>
+                        <a:rPr lang="en-US" sz="1600" dirty="0"/>
+                        <a:t>0.005 **</a:t>
+                      </a:r>
+                    </a:p>
+                    <a:p>
+                      <a:r>
+                        <a:rPr lang="en-US" sz="1600" dirty="0"/>
+                        <a:t>0.005 **</a:t>
+                      </a:r>
+                    </a:p>
+                    <a:p>
+                      <a:r>
+                        <a:rPr lang="en-US" sz="1600" dirty="0"/>
+                        <a:t>0.050 *</a:t>
+                      </a:r>
+                    </a:p>
+                  </a:txBody>
+                  <a:tcPr/>
+                </a:tc>
+                <a:extLst>
+                  <a:ext uri="{0D108BD9-81ED-4DB2-BD59-A6C34878D82A}">
+                    <a16:rowId xmlns:a16="http://schemas.microsoft.com/office/drawing/2014/main" val="3978542847"/>
+                  </a:ext>
+                </a:extLst>
+              </a:tr>
+              <a:tr h="370840">
+                <a:tc>
+                  <a:txBody>
+                    <a:bodyPr/>
+                    <a:lstStyle/>
+                    <a:p>
+                      <a:r>
+                        <a:rPr lang="en-US" sz="1600" dirty="0"/>
+                        <a:t>6 + 10</a:t>
+                      </a:r>
+                    </a:p>
+                  </a:txBody>
+                  <a:tcPr/>
+                </a:tc>
+                <a:tc>
+                  <a:txBody>
+                    <a:bodyPr/>
+                    <a:lstStyle/>
+                    <a:p>
+                      <a:r>
+                        <a:rPr lang="en-US" sz="1600" dirty="0" err="1"/>
+                        <a:t>Ammodytidae</a:t>
+                      </a:r>
+                      <a:endParaRPr lang="en-US" sz="1600" dirty="0"/>
+                    </a:p>
+                  </a:txBody>
+                  <a:tcPr/>
+                </a:tc>
+                <a:tc>
+                  <a:txBody>
+                    <a:bodyPr/>
+                    <a:lstStyle/>
+                    <a:p>
+                      <a:r>
+                        <a:rPr lang="en-US" sz="1600" dirty="0"/>
+                        <a:t>0.005 **</a:t>
+                      </a:r>
+                    </a:p>
+                  </a:txBody>
+                  <a:tcPr/>
+                </a:tc>
+                <a:extLst>
+                  <a:ext uri="{0D108BD9-81ED-4DB2-BD59-A6C34878D82A}">
+                    <a16:rowId xmlns:a16="http://schemas.microsoft.com/office/drawing/2014/main" val="4061474650"/>
+                  </a:ext>
+                </a:extLst>
+              </a:tr>
+            </a:tbl>
+          </a:graphicData>
+        </a:graphic>
+      </p:graphicFrame>
+    </p:spTree>
+    <p:extLst>
+      <p:ext uri="{BB962C8B-B14F-4D97-AF65-F5344CB8AC3E}">
+        <p14:creationId xmlns:p14="http://schemas.microsoft.com/office/powerpoint/2010/main" val="1660356394"/>
+      </p:ext>
+    </p:extLst>
+  </p:cSld>
+  <p:clrMapOvr>
+    <a:masterClrMapping/>
+  </p:clrMapOvr>
+</p:sld>
+</file>
+
+<file path=ppt/slides/slide11.xml><?xml version="1.0" encoding="utf-8"?>
+<p:sld xmlns:a="http://schemas.openxmlformats.org/drawingml/2006/main" xmlns:r="http://schemas.openxmlformats.org/officeDocument/2006/relationships" xmlns:p="http://schemas.openxmlformats.org/presentationml/2006/main">
+  <p:cSld>
+    <p:spTree>
+      <p:nvGrpSpPr>
+        <p:cNvPr id="1" name="">
+          <a:extLst>
+            <a:ext uri="{FF2B5EF4-FFF2-40B4-BE49-F238E27FC236}">
+              <a16:creationId xmlns:a16="http://schemas.microsoft.com/office/drawing/2014/main" id="{7FE2358C-3DED-8623-223A-38B520D15428}"/>
+            </a:ext>
+          </a:extLst>
+        </p:cNvPr>
+        <p:cNvGrpSpPr/>
+        <p:nvPr/>
+      </p:nvGrpSpPr>
+      <p:grpSpPr>
+        <a:xfrm>
+          <a:off x="0" y="0"/>
+          <a:ext cx="0" cy="0"/>
+          <a:chOff x="0" y="0"/>
+          <a:chExt cx="0" cy="0"/>
+        </a:xfrm>
+      </p:grpSpPr>
+      <p:sp>
+        <p:nvSpPr>
+          <p:cNvPr id="4" name="Title 3">
+            <a:extLst>
+              <a:ext uri="{FF2B5EF4-FFF2-40B4-BE49-F238E27FC236}">
+                <a16:creationId xmlns:a16="http://schemas.microsoft.com/office/drawing/2014/main" id="{C2166C8B-63A5-630A-051D-AED281BA7F24}"/>
+              </a:ext>
+            </a:extLst>
+          </p:cNvPr>
+          <p:cNvSpPr>
+            <a:spLocks noGrp="1"/>
+          </p:cNvSpPr>
+          <p:nvPr>
+            <p:ph type="title"/>
+          </p:nvPr>
+        </p:nvSpPr>
+        <p:spPr>
+          <a:xfrm>
+            <a:off x="274938" y="78785"/>
+            <a:ext cx="11642124" cy="1092110"/>
+          </a:xfrm>
+        </p:spPr>
+        <p:txBody>
+          <a:bodyPr>
+            <a:noAutofit/>
+          </a:bodyPr>
+          <a:lstStyle/>
+          <a:p>
+            <a:r>
+              <a:rPr lang="en-US" sz="2000" i="1" dirty="0"/>
+              <a:t>(alternative?) Supplemental Table 1</a:t>
+            </a:r>
+            <a:r>
+              <a:rPr lang="en-US" sz="2000" dirty="0"/>
+              <a:t>: Results of indicator species analysis (ISA) on net tows from four main clusters in the overall AHC. Max number of clusters that can be indicated together set equal to two. Used to verify the dominant taxa for each cluster and the use of clusters as representatives of taxa assemblages.</a:t>
+            </a:r>
+            <a:endParaRPr lang="en-US" sz="2000" i="1" dirty="0"/>
+          </a:p>
+        </p:txBody>
+      </p:sp>
+      <p:graphicFrame>
+        <p:nvGraphicFramePr>
+          <p:cNvPr id="3" name="Table 2">
+            <a:extLst>
+              <a:ext uri="{FF2B5EF4-FFF2-40B4-BE49-F238E27FC236}">
+                <a16:creationId xmlns:a16="http://schemas.microsoft.com/office/drawing/2014/main" id="{30DB109B-E96C-1C40-5475-7D086EA7FA15}"/>
+              </a:ext>
+            </a:extLst>
+          </p:cNvPr>
+          <p:cNvGraphicFramePr>
+            <a:graphicFrameLocks noGrp="1"/>
+          </p:cNvGraphicFramePr>
+          <p:nvPr>
+            <p:extLst>
+              <p:ext uri="{D42A27DB-BD31-4B8C-83A1-F6EECF244321}">
+                <p14:modId xmlns:p14="http://schemas.microsoft.com/office/powerpoint/2010/main" val="2821240553"/>
+              </p:ext>
+            </p:extLst>
+          </p:nvPr>
+        </p:nvGraphicFramePr>
+        <p:xfrm>
+          <a:off x="2032000" y="1064215"/>
+          <a:ext cx="8127999" cy="5715000"/>
+        </p:xfrm>
+        <a:graphic>
+          <a:graphicData uri="http://schemas.openxmlformats.org/drawingml/2006/table">
+            <a:tbl>
+              <a:tblPr firstRow="1" bandRow="1">
+                <a:tableStyleId>{5940675A-B579-460E-94D1-54222C63F5DA}</a:tableStyleId>
+              </a:tblPr>
+              <a:tblGrid>
+                <a:gridCol w="1390822">
+                  <a:extLst>
+                    <a:ext uri="{9D8B030D-6E8A-4147-A177-3AD203B41FA5}">
+                      <a16:colId xmlns:a16="http://schemas.microsoft.com/office/drawing/2014/main" val="3288010381"/>
+                    </a:ext>
+                  </a:extLst>
+                </a:gridCol>
+                <a:gridCol w="4027844">
+                  <a:extLst>
+                    <a:ext uri="{9D8B030D-6E8A-4147-A177-3AD203B41FA5}">
+                      <a16:colId xmlns:a16="http://schemas.microsoft.com/office/drawing/2014/main" val="238683654"/>
+                    </a:ext>
+                  </a:extLst>
+                </a:gridCol>
+                <a:gridCol w="2709333">
+                  <a:extLst>
+                    <a:ext uri="{9D8B030D-6E8A-4147-A177-3AD203B41FA5}">
+                      <a16:colId xmlns:a16="http://schemas.microsoft.com/office/drawing/2014/main" val="2418419917"/>
+                    </a:ext>
+                  </a:extLst>
+                </a:gridCol>
+              </a:tblGrid>
+              <a:tr h="370840">
+                <a:tc>
+                  <a:txBody>
+                    <a:bodyPr/>
+                    <a:lstStyle/>
+                    <a:p>
+                      <a:r>
+                        <a:rPr lang="en-US" sz="1600" dirty="0"/>
+                        <a:t>Cluster(s)</a:t>
+                      </a:r>
+                    </a:p>
+                  </a:txBody>
+                  <a:tcPr/>
+                </a:tc>
+                <a:tc>
+                  <a:txBody>
+                    <a:bodyPr/>
+                    <a:lstStyle/>
+                    <a:p>
+                      <a:r>
+                        <a:rPr lang="en-US" sz="1600" dirty="0"/>
+                        <a:t>Taxa</a:t>
+                      </a:r>
+                    </a:p>
+                  </a:txBody>
+                  <a:tcPr/>
+                </a:tc>
+                <a:tc>
+                  <a:txBody>
+                    <a:bodyPr/>
+                    <a:lstStyle/>
+                    <a:p>
+                      <a:r>
+                        <a:rPr lang="en-US" sz="1600" dirty="0"/>
+                        <a:t>P-value</a:t>
+                      </a:r>
+                    </a:p>
+                  </a:txBody>
+                  <a:tcPr/>
+                </a:tc>
+                <a:extLst>
+                  <a:ext uri="{0D108BD9-81ED-4DB2-BD59-A6C34878D82A}">
+                    <a16:rowId xmlns:a16="http://schemas.microsoft.com/office/drawing/2014/main" val="3621098174"/>
+                  </a:ext>
+                </a:extLst>
+              </a:tr>
+              <a:tr h="370840">
+                <a:tc>
+                  <a:txBody>
+                    <a:bodyPr/>
+                    <a:lstStyle/>
+                    <a:p>
+                      <a:r>
+                        <a:rPr lang="en-US" sz="1600" dirty="0"/>
+                        <a:t>2</a:t>
+                      </a:r>
+                    </a:p>
+                  </a:txBody>
+                  <a:tcPr/>
+                </a:tc>
+                <a:tc>
+                  <a:txBody>
+                    <a:bodyPr/>
+                    <a:lstStyle/>
+                    <a:p>
+                      <a:r>
+                        <a:rPr lang="en-US" sz="1600" dirty="0" err="1"/>
+                        <a:t>Cyclopsettidae</a:t>
+                      </a:r>
+                      <a:endParaRPr lang="en-US" sz="1600" dirty="0"/>
+                    </a:p>
+                  </a:txBody>
+                  <a:tcPr/>
+                </a:tc>
+                <a:tc>
+                  <a:txBody>
+                    <a:bodyPr/>
+                    <a:lstStyle/>
+                    <a:p>
+                      <a:r>
+                        <a:rPr lang="en-US" sz="1600" dirty="0"/>
+                        <a:t>0.005 **</a:t>
+                      </a:r>
+                    </a:p>
+                  </a:txBody>
+                  <a:tcPr/>
+                </a:tc>
+                <a:extLst>
+                  <a:ext uri="{0D108BD9-81ED-4DB2-BD59-A6C34878D82A}">
+                    <a16:rowId xmlns:a16="http://schemas.microsoft.com/office/drawing/2014/main" val="3145787672"/>
+                  </a:ext>
+                </a:extLst>
+              </a:tr>
+              <a:tr h="370840">
+                <a:tc>
+                  <a:txBody>
+                    <a:bodyPr/>
+                    <a:lstStyle/>
+                    <a:p>
+                      <a:r>
+                        <a:rPr lang="en-US" sz="1600" dirty="0"/>
+                        <a:t>3</a:t>
+                      </a:r>
+                    </a:p>
+                  </a:txBody>
+                  <a:tcPr/>
+                </a:tc>
+                <a:tc>
+                  <a:txBody>
+                    <a:bodyPr/>
+                    <a:lstStyle/>
+                    <a:p>
+                      <a:r>
+                        <a:rPr lang="en-US" sz="1600" i="1" dirty="0" err="1"/>
+                        <a:t>Bathylagus</a:t>
+                      </a:r>
+                      <a:r>
+                        <a:rPr lang="en-US" sz="1600" i="1" dirty="0"/>
+                        <a:t> </a:t>
+                      </a:r>
+                      <a:r>
+                        <a:rPr lang="en-US" sz="1600" i="1" dirty="0" err="1"/>
+                        <a:t>ochotensis</a:t>
+                      </a:r>
+                      <a:endParaRPr lang="en-US" sz="1600" i="0" dirty="0"/>
+                    </a:p>
+                    <a:p>
+                      <a:r>
+                        <a:rPr lang="en-US" sz="1600" i="1" dirty="0" err="1"/>
+                        <a:t>Protomyctophum</a:t>
+                      </a:r>
+                      <a:r>
+                        <a:rPr lang="en-US" sz="1600" i="0" dirty="0"/>
+                        <a:t> spp.</a:t>
+                      </a:r>
+                      <a:endParaRPr lang="en-US" sz="1600" i="1" dirty="0"/>
+                    </a:p>
+                  </a:txBody>
+                  <a:tcPr/>
+                </a:tc>
+                <a:tc>
+                  <a:txBody>
+                    <a:bodyPr/>
+                    <a:lstStyle/>
+                    <a:p>
+                      <a:r>
+                        <a:rPr lang="en-US" sz="1600" dirty="0"/>
+                        <a:t>0.005 **</a:t>
+                      </a:r>
+                    </a:p>
+                    <a:p>
+                      <a:r>
+                        <a:rPr lang="en-US" sz="1600" dirty="0"/>
+                        <a:t>0.005 **</a:t>
+                      </a:r>
+                    </a:p>
+                  </a:txBody>
+                  <a:tcPr/>
+                </a:tc>
+                <a:extLst>
+                  <a:ext uri="{0D108BD9-81ED-4DB2-BD59-A6C34878D82A}">
+                    <a16:rowId xmlns:a16="http://schemas.microsoft.com/office/drawing/2014/main" val="1892644640"/>
+                  </a:ext>
+                </a:extLst>
+              </a:tr>
+              <a:tr h="370840">
+                <a:tc>
+                  <a:txBody>
+                    <a:bodyPr/>
+                    <a:lstStyle/>
+                    <a:p>
+                      <a:r>
+                        <a:rPr lang="en-US" sz="1600" dirty="0"/>
+                        <a:t>4</a:t>
+                      </a:r>
+                    </a:p>
+                  </a:txBody>
+                  <a:tcPr/>
+                </a:tc>
+                <a:tc>
+                  <a:txBody>
+                    <a:bodyPr/>
+                    <a:lstStyle/>
+                    <a:p>
+                      <a:r>
+                        <a:rPr lang="en-US" sz="1600" i="0" dirty="0"/>
+                        <a:t>Osmeridae</a:t>
+                      </a:r>
+                    </a:p>
+                    <a:p>
+                      <a:r>
+                        <a:rPr lang="en-US" sz="1600" i="1" dirty="0" err="1"/>
+                        <a:t>Isopsetta</a:t>
+                      </a:r>
+                      <a:r>
+                        <a:rPr lang="en-US" sz="1600" i="1" dirty="0"/>
+                        <a:t> </a:t>
+                      </a:r>
+                      <a:r>
+                        <a:rPr lang="en-US" sz="1600" i="1" dirty="0" err="1"/>
+                        <a:t>isolepis</a:t>
+                      </a:r>
+                      <a:endParaRPr lang="en-US" sz="1600" i="1" dirty="0"/>
+                    </a:p>
+                    <a:p>
+                      <a:r>
+                        <a:rPr lang="en-US" sz="1600" i="1" dirty="0" err="1"/>
+                        <a:t>Psettichthys</a:t>
+                      </a:r>
+                      <a:r>
+                        <a:rPr lang="en-US" sz="1600" i="1" dirty="0"/>
+                        <a:t> </a:t>
+                      </a:r>
+                      <a:r>
+                        <a:rPr lang="en-US" sz="1600" i="1" dirty="0" err="1"/>
+                        <a:t>melanostictus</a:t>
+                      </a:r>
+                      <a:endParaRPr lang="en-US" sz="1600" i="1" dirty="0"/>
+                    </a:p>
+                    <a:p>
+                      <a:r>
+                        <a:rPr lang="en-US" sz="1600" i="0" dirty="0"/>
+                        <a:t>Cottidae</a:t>
+                      </a:r>
+                    </a:p>
+                    <a:p>
+                      <a:r>
+                        <a:rPr lang="en-US" sz="1600" i="0" dirty="0" err="1"/>
+                        <a:t>Gadidae</a:t>
+                      </a:r>
+                      <a:endParaRPr lang="en-US" sz="1600" i="0" dirty="0"/>
+                    </a:p>
+                  </a:txBody>
+                  <a:tcPr/>
+                </a:tc>
+                <a:tc>
+                  <a:txBody>
+                    <a:bodyPr/>
+                    <a:lstStyle/>
+                    <a:p>
+                      <a:r>
+                        <a:rPr lang="en-US" sz="1600" dirty="0"/>
+                        <a:t>0.005 **</a:t>
+                      </a:r>
+                    </a:p>
+                    <a:p>
+                      <a:r>
+                        <a:rPr lang="en-US" sz="1600" dirty="0"/>
+                        <a:t>0.005 **</a:t>
+                      </a:r>
+                    </a:p>
+                    <a:p>
+                      <a:r>
+                        <a:rPr lang="en-US" sz="1600" dirty="0"/>
+                        <a:t>0.005 **</a:t>
+                      </a:r>
+                    </a:p>
+                    <a:p>
+                      <a:r>
+                        <a:rPr lang="en-US" sz="1600" dirty="0"/>
+                        <a:t>0.005 **</a:t>
+                      </a:r>
+                    </a:p>
+                    <a:p>
+                      <a:r>
+                        <a:rPr lang="en-US" sz="1600" dirty="0"/>
+                        <a:t>0.005 **</a:t>
+                      </a:r>
+                    </a:p>
+                  </a:txBody>
+                  <a:tcPr/>
+                </a:tc>
+                <a:extLst>
+                  <a:ext uri="{0D108BD9-81ED-4DB2-BD59-A6C34878D82A}">
+                    <a16:rowId xmlns:a16="http://schemas.microsoft.com/office/drawing/2014/main" val="2227666454"/>
+                  </a:ext>
+                </a:extLst>
+              </a:tr>
+              <a:tr h="370840">
+                <a:tc>
+                  <a:txBody>
+                    <a:bodyPr/>
+                    <a:lstStyle/>
+                    <a:p>
+                      <a:r>
+                        <a:rPr lang="en-US" sz="1600" dirty="0"/>
+                        <a:t>1 + 2</a:t>
+                      </a:r>
+                    </a:p>
+                  </a:txBody>
+                  <a:tcPr/>
+                </a:tc>
+                <a:tc>
+                  <a:txBody>
+                    <a:bodyPr/>
+                    <a:lstStyle/>
+                    <a:p>
+                      <a:r>
+                        <a:rPr lang="en-US" sz="1600" i="1" dirty="0"/>
+                        <a:t>Sebastes </a:t>
+                      </a:r>
+                      <a:r>
+                        <a:rPr lang="en-US" sz="1600" i="0" dirty="0"/>
+                        <a:t>spp.</a:t>
+                      </a:r>
+                    </a:p>
+                    <a:p>
+                      <a:r>
+                        <a:rPr lang="en-US" sz="1600" i="1" dirty="0" err="1"/>
+                        <a:t>Glyptocephalus</a:t>
+                      </a:r>
+                      <a:r>
+                        <a:rPr lang="en-US" sz="1600" i="1" dirty="0"/>
+                        <a:t> </a:t>
+                      </a:r>
+                      <a:r>
+                        <a:rPr lang="en-US" sz="1600" i="1" dirty="0" err="1"/>
+                        <a:t>zachirus</a:t>
+                      </a:r>
+                      <a:endParaRPr lang="en-US" sz="1600" i="1" dirty="0"/>
+                    </a:p>
+                  </a:txBody>
+                  <a:tcPr/>
+                </a:tc>
+                <a:tc>
+                  <a:txBody>
+                    <a:bodyPr/>
+                    <a:lstStyle/>
+                    <a:p>
+                      <a:r>
+                        <a:rPr lang="en-US" sz="1600" dirty="0"/>
+                        <a:t>0.005 **</a:t>
+                      </a:r>
+                    </a:p>
+                    <a:p>
+                      <a:r>
+                        <a:rPr lang="en-US" sz="1600" dirty="0"/>
+                        <a:t>0.005 **</a:t>
+                      </a:r>
+                    </a:p>
+                  </a:txBody>
+                  <a:tcPr/>
+                </a:tc>
+                <a:extLst>
+                  <a:ext uri="{0D108BD9-81ED-4DB2-BD59-A6C34878D82A}">
+                    <a16:rowId xmlns:a16="http://schemas.microsoft.com/office/drawing/2014/main" val="3253798277"/>
+                  </a:ext>
+                </a:extLst>
+              </a:tr>
+              <a:tr h="370840">
+                <a:tc>
+                  <a:txBody>
+                    <a:bodyPr/>
+                    <a:lstStyle/>
+                    <a:p>
+                      <a:r>
+                        <a:rPr lang="en-US" sz="1600" dirty="0"/>
+                        <a:t>1 + 3</a:t>
+                      </a:r>
+                    </a:p>
+                  </a:txBody>
+                  <a:tcPr/>
+                </a:tc>
+                <a:tc>
+                  <a:txBody>
+                    <a:bodyPr/>
+                    <a:lstStyle/>
+                    <a:p>
+                      <a:r>
+                        <a:rPr lang="en-US" sz="1600" i="1" dirty="0" err="1"/>
+                        <a:t>Stenobrachius</a:t>
+                      </a:r>
+                      <a:r>
+                        <a:rPr lang="en-US" sz="1600" i="1" dirty="0"/>
+                        <a:t> </a:t>
+                      </a:r>
+                      <a:r>
+                        <a:rPr lang="en-US" sz="1600" i="1" dirty="0" err="1"/>
+                        <a:t>leucopsarus</a:t>
+                      </a:r>
+                      <a:endParaRPr lang="en-US" sz="1600" i="1" dirty="0"/>
+                    </a:p>
+                    <a:p>
+                      <a:r>
+                        <a:rPr lang="en-US" sz="1600" i="1" dirty="0" err="1"/>
+                        <a:t>Tarletonbenia</a:t>
+                      </a:r>
+                      <a:r>
+                        <a:rPr lang="en-US" sz="1600" i="1" dirty="0"/>
+                        <a:t> </a:t>
+                      </a:r>
+                      <a:r>
+                        <a:rPr lang="en-US" sz="1600" i="1" dirty="0" err="1"/>
+                        <a:t>crenularis</a:t>
+                      </a:r>
+                      <a:endParaRPr lang="en-US" sz="1600" i="1" dirty="0"/>
+                    </a:p>
+                  </a:txBody>
+                  <a:tcPr/>
+                </a:tc>
+                <a:tc>
+                  <a:txBody>
+                    <a:bodyPr/>
+                    <a:lstStyle/>
+                    <a:p>
+                      <a:r>
+                        <a:rPr lang="en-US" sz="1600" dirty="0"/>
+                        <a:t>0.005 **</a:t>
+                      </a:r>
+                    </a:p>
+                    <a:p>
+                      <a:r>
+                        <a:rPr lang="en-US" sz="1600" dirty="0"/>
+                        <a:t>0.005 **</a:t>
+                      </a:r>
+                    </a:p>
+                  </a:txBody>
+                  <a:tcPr/>
+                </a:tc>
+                <a:extLst>
+                  <a:ext uri="{0D108BD9-81ED-4DB2-BD59-A6C34878D82A}">
+                    <a16:rowId xmlns:a16="http://schemas.microsoft.com/office/drawing/2014/main" val="2364807414"/>
+                  </a:ext>
+                </a:extLst>
+              </a:tr>
+              <a:tr h="370840">
+                <a:tc>
+                  <a:txBody>
+                    <a:bodyPr/>
+                    <a:lstStyle/>
+                    <a:p>
+                      <a:r>
+                        <a:rPr lang="en-US" sz="1600" dirty="0"/>
+                        <a:t>1 + 4</a:t>
+                      </a:r>
+                    </a:p>
+                  </a:txBody>
+                  <a:tcPr/>
+                </a:tc>
+                <a:tc>
+                  <a:txBody>
+                    <a:bodyPr/>
+                    <a:lstStyle/>
+                    <a:p>
+                      <a:r>
+                        <a:rPr lang="en-US" sz="1600" i="1" dirty="0" err="1"/>
+                        <a:t>Hemilepidotus</a:t>
+                      </a:r>
+                      <a:r>
+                        <a:rPr lang="en-US" sz="1600" i="1" dirty="0"/>
+                        <a:t> </a:t>
+                      </a:r>
+                      <a:r>
+                        <a:rPr lang="en-US" sz="1600" i="0" dirty="0"/>
+                        <a:t>spp.</a:t>
+                      </a:r>
+                      <a:endParaRPr lang="en-US" sz="1600" i="1" dirty="0"/>
+                    </a:p>
+                  </a:txBody>
+                  <a:tcPr/>
+                </a:tc>
+                <a:tc>
+                  <a:txBody>
+                    <a:bodyPr/>
+                    <a:lstStyle/>
+                    <a:p>
+                      <a:r>
+                        <a:rPr lang="en-US" sz="1600" dirty="0"/>
+                        <a:t>0.02 *</a:t>
+                      </a:r>
+                    </a:p>
+                  </a:txBody>
+                  <a:tcPr/>
+                </a:tc>
+                <a:extLst>
+                  <a:ext uri="{0D108BD9-81ED-4DB2-BD59-A6C34878D82A}">
+                    <a16:rowId xmlns:a16="http://schemas.microsoft.com/office/drawing/2014/main" val="4229098351"/>
+                  </a:ext>
+                </a:extLst>
+              </a:tr>
+              <a:tr h="370840">
+                <a:tc>
+                  <a:txBody>
+                    <a:bodyPr/>
+                    <a:lstStyle/>
+                    <a:p>
+                      <a:r>
+                        <a:rPr lang="en-US" sz="1600" dirty="0"/>
+                        <a:t>2 + 4</a:t>
+                      </a:r>
+                    </a:p>
+                  </a:txBody>
+                  <a:tcPr/>
+                </a:tc>
+                <a:tc>
+                  <a:txBody>
+                    <a:bodyPr/>
+                    <a:lstStyle/>
+                    <a:p>
+                      <a:r>
+                        <a:rPr lang="en-US" sz="1600" i="1" dirty="0" err="1"/>
+                        <a:t>Parophrys</a:t>
+                      </a:r>
+                      <a:r>
+                        <a:rPr lang="en-US" sz="1600" i="1" dirty="0"/>
+                        <a:t> </a:t>
+                      </a:r>
+                      <a:r>
+                        <a:rPr lang="en-US" sz="1600" i="1" dirty="0" err="1"/>
+                        <a:t>vetulus</a:t>
+                      </a:r>
+                      <a:endParaRPr lang="en-US" sz="1600" i="1" dirty="0"/>
+                    </a:p>
+                    <a:p>
+                      <a:r>
+                        <a:rPr lang="en-US" sz="1600" i="0" dirty="0" err="1"/>
+                        <a:t>Ammodytidae</a:t>
+                      </a:r>
+                      <a:endParaRPr lang="en-US" sz="1600" i="0" dirty="0"/>
+                    </a:p>
+                    <a:p>
+                      <a:r>
+                        <a:rPr lang="en-US" sz="1600" i="1" dirty="0"/>
+                        <a:t>Liparis</a:t>
+                      </a:r>
+                      <a:r>
+                        <a:rPr lang="en-US" sz="1600" i="0" dirty="0"/>
+                        <a:t> spp.</a:t>
+                      </a:r>
+                    </a:p>
+                    <a:p>
+                      <a:r>
+                        <a:rPr lang="en-US" sz="1600" i="0" dirty="0" err="1"/>
+                        <a:t>Hexagrammidae</a:t>
+                      </a:r>
+                      <a:endParaRPr lang="en-US" sz="1600" i="0" dirty="0"/>
+                    </a:p>
+                    <a:p>
+                      <a:r>
+                        <a:rPr lang="en-US" sz="1600" i="0" dirty="0" err="1"/>
+                        <a:t>Psychrolutidae</a:t>
+                      </a:r>
+                      <a:endParaRPr lang="en-US" sz="1600" i="0" dirty="0"/>
+                    </a:p>
+                    <a:p>
+                      <a:r>
+                        <a:rPr lang="en-US" sz="1600" i="1" dirty="0" err="1"/>
+                        <a:t>Scropaenichthys</a:t>
+                      </a:r>
+                      <a:r>
+                        <a:rPr lang="en-US" sz="1600" i="1" dirty="0"/>
+                        <a:t> marmoratus</a:t>
+                      </a:r>
+                    </a:p>
+                  </a:txBody>
+                  <a:tcPr/>
+                </a:tc>
+                <a:tc>
+                  <a:txBody>
+                    <a:bodyPr/>
+                    <a:lstStyle/>
+                    <a:p>
+                      <a:r>
+                        <a:rPr lang="en-US" sz="1600" dirty="0"/>
+                        <a:t>0.005 **</a:t>
+                      </a:r>
+                    </a:p>
+                    <a:p>
+                      <a:r>
+                        <a:rPr lang="en-US" sz="1600" dirty="0"/>
+                        <a:t>0.005 **</a:t>
+                      </a:r>
+                    </a:p>
+                    <a:p>
+                      <a:r>
+                        <a:rPr lang="en-US" sz="1600" dirty="0"/>
+                        <a:t>0.005 **</a:t>
+                      </a:r>
+                    </a:p>
+                    <a:p>
+                      <a:r>
+                        <a:rPr lang="en-US" sz="1600" dirty="0"/>
+                        <a:t>0.005 **</a:t>
+                      </a:r>
+                    </a:p>
+                    <a:p>
+                      <a:r>
+                        <a:rPr lang="en-US" sz="1600" dirty="0"/>
+                        <a:t>0.010 **</a:t>
+                      </a:r>
+                    </a:p>
+                    <a:p>
+                      <a:r>
+                        <a:rPr lang="en-US" sz="1600" dirty="0"/>
+                        <a:t>0.050 **</a:t>
+                      </a:r>
+                    </a:p>
+                  </a:txBody>
+                  <a:tcPr/>
+                </a:tc>
+                <a:extLst>
+                  <a:ext uri="{0D108BD9-81ED-4DB2-BD59-A6C34878D82A}">
+                    <a16:rowId xmlns:a16="http://schemas.microsoft.com/office/drawing/2014/main" val="1711312673"/>
+                  </a:ext>
+                </a:extLst>
+              </a:tr>
+            </a:tbl>
+          </a:graphicData>
+        </a:graphic>
+      </p:graphicFrame>
+    </p:spTree>
+    <p:extLst>
+      <p:ext uri="{BB962C8B-B14F-4D97-AF65-F5344CB8AC3E}">
+        <p14:creationId xmlns:p14="http://schemas.microsoft.com/office/powerpoint/2010/main" val="646512240"/>
+      </p:ext>
+    </p:extLst>
+  </p:cSld>
+  <p:clrMapOvr>
+    <a:masterClrMapping/>
+  </p:clrMapOvr>
+</p:sld>
+</file>
+
+<file path=ppt/slides/slide12.xml><?xml version="1.0" encoding="utf-8"?>
+<p:sld xmlns:a="http://schemas.openxmlformats.org/drawingml/2006/main" xmlns:r="http://schemas.openxmlformats.org/officeDocument/2006/relationships" xmlns:p="http://schemas.openxmlformats.org/presentationml/2006/main">
+  <p:cSld>
+    <p:spTree>
+      <p:nvGrpSpPr>
+        <p:cNvPr id="1" name="">
+          <a:extLst>
+            <a:ext uri="{FF2B5EF4-FFF2-40B4-BE49-F238E27FC236}">
               <a16:creationId xmlns:a16="http://schemas.microsoft.com/office/drawing/2014/main" id="{E1D2D393-2834-41E5-D35A-B2AE1946B4F2}"/>
             </a:ext>
           </a:extLst>
@@ -3952,6 +5363,196 @@
   <p:cSld>
     <p:spTree>
       <p:nvGrpSpPr>
+        <p:cNvPr id="1" name="">
+          <a:extLst>
+            <a:ext uri="{FF2B5EF4-FFF2-40B4-BE49-F238E27FC236}">
+              <a16:creationId xmlns:a16="http://schemas.microsoft.com/office/drawing/2014/main" id="{FF622ABA-C215-5271-A2A3-045BC7A16283}"/>
+            </a:ext>
+          </a:extLst>
+        </p:cNvPr>
+        <p:cNvGrpSpPr/>
+        <p:nvPr/>
+      </p:nvGrpSpPr>
+      <p:grpSpPr>
+        <a:xfrm>
+          <a:off x="0" y="0"/>
+          <a:ext cx="0" cy="0"/>
+          <a:chOff x="0" y="0"/>
+          <a:chExt cx="0" cy="0"/>
+        </a:xfrm>
+      </p:grpSpPr>
+      <p:sp>
+        <p:nvSpPr>
+          <p:cNvPr id="4" name="Title 3">
+            <a:extLst>
+              <a:ext uri="{FF2B5EF4-FFF2-40B4-BE49-F238E27FC236}">
+                <a16:creationId xmlns:a16="http://schemas.microsoft.com/office/drawing/2014/main" id="{EED71206-5DEB-59B9-58B9-E3E8535388C6}"/>
+              </a:ext>
+            </a:extLst>
+          </p:cNvPr>
+          <p:cNvSpPr>
+            <a:spLocks noGrp="1"/>
+          </p:cNvSpPr>
+          <p:nvPr>
+            <p:ph type="title"/>
+          </p:nvPr>
+        </p:nvSpPr>
+        <p:spPr/>
+        <p:txBody>
+          <a:bodyPr/>
+          <a:lstStyle/>
+          <a:p>
+            <a:r>
+              <a:rPr lang="en-US" dirty="0"/>
+              <a:t>Objective 2</a:t>
+            </a:r>
+          </a:p>
+        </p:txBody>
+      </p:sp>
+      <p:sp>
+        <p:nvSpPr>
+          <p:cNvPr id="5" name="Text Placeholder 4">
+            <a:extLst>
+              <a:ext uri="{FF2B5EF4-FFF2-40B4-BE49-F238E27FC236}">
+                <a16:creationId xmlns:a16="http://schemas.microsoft.com/office/drawing/2014/main" id="{6D82CA60-3EAB-EE79-1D86-2021B3B5417A}"/>
+              </a:ext>
+            </a:extLst>
+          </p:cNvPr>
+          <p:cNvSpPr>
+            <a:spLocks noGrp="1"/>
+          </p:cNvSpPr>
+          <p:nvPr>
+            <p:ph type="body" idx="1"/>
+          </p:nvPr>
+        </p:nvSpPr>
+        <p:spPr/>
+        <p:txBody>
+          <a:bodyPr/>
+          <a:lstStyle/>
+          <a:p>
+            <a:r>
+              <a:rPr lang="en-US" dirty="0"/>
+              <a:t>Quantify the effects of spatiotemporal and environmental variables on assemblage composition</a:t>
+            </a:r>
+          </a:p>
+          <a:p>
+            <a:endParaRPr lang="en-US" dirty="0"/>
+          </a:p>
+        </p:txBody>
+      </p:sp>
+    </p:spTree>
+    <p:extLst>
+      <p:ext uri="{BB962C8B-B14F-4D97-AF65-F5344CB8AC3E}">
+        <p14:creationId xmlns:p14="http://schemas.microsoft.com/office/powerpoint/2010/main" val="4010563470"/>
+      </p:ext>
+    </p:extLst>
+  </p:cSld>
+  <p:clrMapOvr>
+    <a:masterClrMapping/>
+  </p:clrMapOvr>
+</p:sld>
+</file>
+
+<file path=ppt/slides/slide4.xml><?xml version="1.0" encoding="utf-8"?>
+<p:sld xmlns:a="http://schemas.openxmlformats.org/drawingml/2006/main" xmlns:r="http://schemas.openxmlformats.org/officeDocument/2006/relationships" xmlns:p="http://schemas.openxmlformats.org/presentationml/2006/main">
+  <p:cSld>
+    <p:spTree>
+      <p:nvGrpSpPr>
+        <p:cNvPr id="1" name="">
+          <a:extLst>
+            <a:ext uri="{FF2B5EF4-FFF2-40B4-BE49-F238E27FC236}">
+              <a16:creationId xmlns:a16="http://schemas.microsoft.com/office/drawing/2014/main" id="{B5BA26DD-F1D0-9B07-C1B3-8A0FA2A40C37}"/>
+            </a:ext>
+          </a:extLst>
+        </p:cNvPr>
+        <p:cNvGrpSpPr/>
+        <p:nvPr/>
+      </p:nvGrpSpPr>
+      <p:grpSpPr>
+        <a:xfrm>
+          <a:off x="0" y="0"/>
+          <a:ext cx="0" cy="0"/>
+          <a:chOff x="0" y="0"/>
+          <a:chExt cx="0" cy="0"/>
+        </a:xfrm>
+      </p:grpSpPr>
+      <p:sp>
+        <p:nvSpPr>
+          <p:cNvPr id="4" name="Title 3">
+            <a:extLst>
+              <a:ext uri="{FF2B5EF4-FFF2-40B4-BE49-F238E27FC236}">
+                <a16:creationId xmlns:a16="http://schemas.microsoft.com/office/drawing/2014/main" id="{DD50304E-E4A7-EF2C-3D5C-CB8F9AA1E942}"/>
+              </a:ext>
+            </a:extLst>
+          </p:cNvPr>
+          <p:cNvSpPr>
+            <a:spLocks noGrp="1"/>
+          </p:cNvSpPr>
+          <p:nvPr>
+            <p:ph type="title"/>
+          </p:nvPr>
+        </p:nvSpPr>
+        <p:spPr/>
+        <p:txBody>
+          <a:bodyPr/>
+          <a:lstStyle/>
+          <a:p>
+            <a:r>
+              <a:rPr lang="en-US" dirty="0"/>
+              <a:t>Objective 3</a:t>
+            </a:r>
+          </a:p>
+        </p:txBody>
+      </p:sp>
+      <p:sp>
+        <p:nvSpPr>
+          <p:cNvPr id="5" name="Text Placeholder 4">
+            <a:extLst>
+              <a:ext uri="{FF2B5EF4-FFF2-40B4-BE49-F238E27FC236}">
+                <a16:creationId xmlns:a16="http://schemas.microsoft.com/office/drawing/2014/main" id="{96598701-C0E7-8830-851B-70B89A3BCD13}"/>
+              </a:ext>
+            </a:extLst>
+          </p:cNvPr>
+          <p:cNvSpPr>
+            <a:spLocks noGrp="1"/>
+          </p:cNvSpPr>
+          <p:nvPr>
+            <p:ph type="body" idx="1"/>
+          </p:nvPr>
+        </p:nvSpPr>
+        <p:spPr/>
+        <p:txBody>
+          <a:bodyPr/>
+          <a:lstStyle/>
+          <a:p>
+            <a:r>
+              <a:rPr lang="en-US" dirty="0"/>
+              <a:t>Assess how vertical position of larvae differs between day and night</a:t>
+            </a:r>
+          </a:p>
+          <a:p>
+            <a:endParaRPr lang="en-US" dirty="0"/>
+          </a:p>
+        </p:txBody>
+      </p:sp>
+    </p:spTree>
+    <p:extLst>
+      <p:ext uri="{BB962C8B-B14F-4D97-AF65-F5344CB8AC3E}">
+        <p14:creationId xmlns:p14="http://schemas.microsoft.com/office/powerpoint/2010/main" val="2827154758"/>
+      </p:ext>
+    </p:extLst>
+  </p:cSld>
+  <p:clrMapOvr>
+    <a:masterClrMapping/>
+  </p:clrMapOvr>
+</p:sld>
+</file>
+
+<file path=ppt/slides/slide5.xml><?xml version="1.0" encoding="utf-8"?>
+<p:sld xmlns:a="http://schemas.openxmlformats.org/drawingml/2006/main" xmlns:r="http://schemas.openxmlformats.org/officeDocument/2006/relationships" xmlns:p="http://schemas.openxmlformats.org/presentationml/2006/main">
+  <p:cSld>
+    <p:spTree>
+      <p:nvGrpSpPr>
         <p:cNvPr id="1" name=""/>
         <p:cNvGrpSpPr/>
         <p:nvPr/>
@@ -4005,7 +5606,7 @@
 </p:sld>
 </file>
 
-<file path=ppt/slides/slide4.xml><?xml version="1.0" encoding="utf-8"?>
+<file path=ppt/slides/slide6.xml><?xml version="1.0" encoding="utf-8"?>
 <p:sld xmlns:a="http://schemas.openxmlformats.org/drawingml/2006/main" xmlns:r="http://schemas.openxmlformats.org/officeDocument/2006/relationships" xmlns:p="http://schemas.openxmlformats.org/presentationml/2006/main">
   <p:cSld>
     <p:spTree>
@@ -4111,7 +5712,7 @@
 </p:sld>
 </file>
 
-<file path=ppt/slides/slide5.xml><?xml version="1.0" encoding="utf-8"?>
+<file path=ppt/slides/slide7.xml><?xml version="1.0" encoding="utf-8"?>
 <p:sld xmlns:a="http://schemas.openxmlformats.org/drawingml/2006/main" xmlns:r="http://schemas.openxmlformats.org/officeDocument/2006/relationships" xmlns:p="http://schemas.openxmlformats.org/presentationml/2006/main">
   <p:cSld>
     <p:spTree>
@@ -4223,7 +5824,7 @@
 </p:sld>
 </file>
 
-<file path=ppt/slides/slide6.xml><?xml version="1.0" encoding="utf-8"?>
+<file path=ppt/slides/slide8.xml><?xml version="1.0" encoding="utf-8"?>
 <p:sld xmlns:a="http://schemas.openxmlformats.org/drawingml/2006/main" xmlns:r="http://schemas.openxmlformats.org/officeDocument/2006/relationships" xmlns:p="http://schemas.openxmlformats.org/presentationml/2006/main">
   <p:cSld>
     <p:spTree>
@@ -4286,6 +5887,78 @@
           </a:p>
         </p:txBody>
       </p:sp>
+      <p:pic>
+        <p:nvPicPr>
+          <p:cNvPr id="12" name="Picture 11">
+            <a:extLst>
+              <a:ext uri="{FF2B5EF4-FFF2-40B4-BE49-F238E27FC236}">
+                <a16:creationId xmlns:a16="http://schemas.microsoft.com/office/drawing/2014/main" id="{75358480-967E-EB28-E15E-D655C65A741E}"/>
+              </a:ext>
+            </a:extLst>
+          </p:cNvPr>
+          <p:cNvPicPr>
+            <a:picLocks noChangeAspect="1"/>
+          </p:cNvPicPr>
+          <p:nvPr/>
+        </p:nvPicPr>
+        <p:blipFill>
+          <a:blip r:embed="rId2">
+            <a:extLst>
+              <a:ext uri="{28A0092B-C50C-407E-A947-70E740481C1C}">
+                <a14:useLocalDpi xmlns:a14="http://schemas.microsoft.com/office/drawing/2010/main" val="0"/>
+              </a:ext>
+            </a:extLst>
+          </a:blip>
+          <a:stretch>
+            <a:fillRect/>
+          </a:stretch>
+        </p:blipFill>
+        <p:spPr>
+          <a:xfrm>
+            <a:off x="133956" y="434634"/>
+            <a:ext cx="10187753" cy="5093876"/>
+          </a:xfrm>
+          <a:prstGeom prst="rect">
+            <a:avLst/>
+          </a:prstGeom>
+        </p:spPr>
+      </p:pic>
+      <p:pic>
+        <p:nvPicPr>
+          <p:cNvPr id="10" name="Picture 9">
+            <a:extLst>
+              <a:ext uri="{FF2B5EF4-FFF2-40B4-BE49-F238E27FC236}">
+                <a16:creationId xmlns:a16="http://schemas.microsoft.com/office/drawing/2014/main" id="{9C6A8FAE-3197-53DB-081A-9F9B8B47FDB8}"/>
+              </a:ext>
+            </a:extLst>
+          </p:cNvPr>
+          <p:cNvPicPr>
+            <a:picLocks noChangeAspect="1"/>
+          </p:cNvPicPr>
+          <p:nvPr/>
+        </p:nvPicPr>
+        <p:blipFill>
+          <a:blip r:embed="rId3">
+            <a:extLst>
+              <a:ext uri="{28A0092B-C50C-407E-A947-70E740481C1C}">
+                <a14:useLocalDpi xmlns:a14="http://schemas.microsoft.com/office/drawing/2010/main" val="0"/>
+              </a:ext>
+            </a:extLst>
+          </a:blip>
+          <a:stretch>
+            <a:fillRect/>
+          </a:stretch>
+        </p:blipFill>
+        <p:spPr>
+          <a:xfrm>
+            <a:off x="10229240" y="333633"/>
+            <a:ext cx="1828804" cy="5486411"/>
+          </a:xfrm>
+          <a:prstGeom prst="rect">
+            <a:avLst/>
+          </a:prstGeom>
+        </p:spPr>
+      </p:pic>
     </p:spTree>
     <p:extLst>
       <p:ext uri="{BB962C8B-B14F-4D97-AF65-F5344CB8AC3E}">
@@ -4299,7 +5972,7 @@
 </p:sld>
 </file>
 
-<file path=ppt/slides/slide7.xml><?xml version="1.0" encoding="utf-8"?>
+<file path=ppt/slides/slide9.xml><?xml version="1.0" encoding="utf-8"?>
 <p:sld xmlns:a="http://schemas.openxmlformats.org/drawingml/2006/main" xmlns:r="http://schemas.openxmlformats.org/officeDocument/2006/relationships" xmlns:p="http://schemas.openxmlformats.org/presentationml/2006/main">
   <p:cSld>
     <p:spTree>
@@ -4362,162 +6035,82 @@
           </a:p>
         </p:txBody>
       </p:sp>
+      <p:pic>
+        <p:nvPicPr>
+          <p:cNvPr id="6" name="Picture 5">
+            <a:extLst>
+              <a:ext uri="{FF2B5EF4-FFF2-40B4-BE49-F238E27FC236}">
+                <a16:creationId xmlns:a16="http://schemas.microsoft.com/office/drawing/2014/main" id="{4B26AA83-1CB4-189B-1A11-1A9E458DE720}"/>
+              </a:ext>
+            </a:extLst>
+          </p:cNvPr>
+          <p:cNvPicPr>
+            <a:picLocks noChangeAspect="1"/>
+          </p:cNvPicPr>
+          <p:nvPr/>
+        </p:nvPicPr>
+        <p:blipFill>
+          <a:blip r:embed="rId2">
+            <a:extLst>
+              <a:ext uri="{28A0092B-C50C-407E-A947-70E740481C1C}">
+                <a14:useLocalDpi xmlns:a14="http://schemas.microsoft.com/office/drawing/2010/main" val="0"/>
+              </a:ext>
+            </a:extLst>
+          </a:blip>
+          <a:stretch>
+            <a:fillRect/>
+          </a:stretch>
+        </p:blipFill>
+        <p:spPr>
+          <a:xfrm>
+            <a:off x="0" y="333633"/>
+            <a:ext cx="9998249" cy="4999124"/>
+          </a:xfrm>
+          <a:prstGeom prst="rect">
+            <a:avLst/>
+          </a:prstGeom>
+        </p:spPr>
+      </p:pic>
+      <p:pic>
+        <p:nvPicPr>
+          <p:cNvPr id="8" name="Picture 7">
+            <a:extLst>
+              <a:ext uri="{FF2B5EF4-FFF2-40B4-BE49-F238E27FC236}">
+                <a16:creationId xmlns:a16="http://schemas.microsoft.com/office/drawing/2014/main" id="{FCDC7F1C-0850-D1F0-004B-C25FF84E6A24}"/>
+              </a:ext>
+            </a:extLst>
+          </p:cNvPr>
+          <p:cNvPicPr>
+            <a:picLocks noChangeAspect="1"/>
+          </p:cNvPicPr>
+          <p:nvPr/>
+        </p:nvPicPr>
+        <p:blipFill>
+          <a:blip r:embed="rId3">
+            <a:extLst>
+              <a:ext uri="{28A0092B-C50C-407E-A947-70E740481C1C}">
+                <a14:useLocalDpi xmlns:a14="http://schemas.microsoft.com/office/drawing/2010/main" val="0"/>
+              </a:ext>
+            </a:extLst>
+          </a:blip>
+          <a:stretch>
+            <a:fillRect/>
+          </a:stretch>
+        </p:blipFill>
+        <p:spPr>
+          <a:xfrm>
+            <a:off x="9922041" y="89989"/>
+            <a:ext cx="1828804" cy="5486411"/>
+          </a:xfrm>
+          <a:prstGeom prst="rect">
+            <a:avLst/>
+          </a:prstGeom>
+        </p:spPr>
+      </p:pic>
     </p:spTree>
     <p:extLst>
       <p:ext uri="{BB962C8B-B14F-4D97-AF65-F5344CB8AC3E}">
         <p14:creationId xmlns:p14="http://schemas.microsoft.com/office/powerpoint/2010/main" val="669740212"/>
-      </p:ext>
-    </p:extLst>
-  </p:cSld>
-  <p:clrMapOvr>
-    <a:masterClrMapping/>
-  </p:clrMapOvr>
-</p:sld>
-</file>
-
-<file path=ppt/slides/slide8.xml><?xml version="1.0" encoding="utf-8"?>
-<p:sld xmlns:a="http://schemas.openxmlformats.org/drawingml/2006/main" xmlns:r="http://schemas.openxmlformats.org/officeDocument/2006/relationships" xmlns:p="http://schemas.openxmlformats.org/presentationml/2006/main">
-  <p:cSld>
-    <p:spTree>
-      <p:nvGrpSpPr>
-        <p:cNvPr id="1" name="">
-          <a:extLst>
-            <a:ext uri="{FF2B5EF4-FFF2-40B4-BE49-F238E27FC236}">
-              <a16:creationId xmlns:a16="http://schemas.microsoft.com/office/drawing/2014/main" id="{FFD4A439-88E8-8DB4-11B1-CBEAB3CB71D2}"/>
-            </a:ext>
-          </a:extLst>
-        </p:cNvPr>
-        <p:cNvGrpSpPr/>
-        <p:nvPr/>
-      </p:nvGrpSpPr>
-      <p:grpSpPr>
-        <a:xfrm>
-          <a:off x="0" y="0"/>
-          <a:ext cx="0" cy="0"/>
-          <a:chOff x="0" y="0"/>
-          <a:chExt cx="0" cy="0"/>
-        </a:xfrm>
-      </p:grpSpPr>
-      <p:sp>
-        <p:nvSpPr>
-          <p:cNvPr id="4" name="Title 3">
-            <a:extLst>
-              <a:ext uri="{FF2B5EF4-FFF2-40B4-BE49-F238E27FC236}">
-                <a16:creationId xmlns:a16="http://schemas.microsoft.com/office/drawing/2014/main" id="{648F083A-692A-C5EF-ED97-F63B76F80265}"/>
-              </a:ext>
-            </a:extLst>
-          </p:cNvPr>
-          <p:cNvSpPr>
-            <a:spLocks noGrp="1"/>
-          </p:cNvSpPr>
-          <p:nvPr>
-            <p:ph type="title"/>
-          </p:nvPr>
-        </p:nvSpPr>
-        <p:spPr>
-          <a:xfrm>
-            <a:off x="838200" y="206439"/>
-            <a:ext cx="10515600" cy="759339"/>
-          </a:xfrm>
-        </p:spPr>
-        <p:txBody>
-          <a:bodyPr>
-            <a:noAutofit/>
-          </a:bodyPr>
-          <a:lstStyle/>
-          <a:p>
-            <a:r>
-              <a:rPr lang="en-US" sz="2000" i="1" dirty="0"/>
-              <a:t>Supplemental Table 1</a:t>
-            </a:r>
-            <a:r>
-              <a:rPr lang="en-US" sz="2000" dirty="0"/>
-              <a:t>: Results of indicator species analysis (ISA) on net tows clustered by AHC. Max number of clusters that can be indicated together set equal to two. Used to verify the dominant taxa for each cluster and the use of clusters as representatives of taxa assemblages.</a:t>
-            </a:r>
-            <a:endParaRPr lang="en-US" sz="2000" i="1" dirty="0"/>
-          </a:p>
-        </p:txBody>
-      </p:sp>
-    </p:spTree>
-    <p:extLst>
-      <p:ext uri="{BB962C8B-B14F-4D97-AF65-F5344CB8AC3E}">
-        <p14:creationId xmlns:p14="http://schemas.microsoft.com/office/powerpoint/2010/main" val="1660356394"/>
-      </p:ext>
-    </p:extLst>
-  </p:cSld>
-  <p:clrMapOvr>
-    <a:masterClrMapping/>
-  </p:clrMapOvr>
-</p:sld>
-</file>
-
-<file path=ppt/slides/slide9.xml><?xml version="1.0" encoding="utf-8"?>
-<p:sld xmlns:a="http://schemas.openxmlformats.org/drawingml/2006/main" xmlns:r="http://schemas.openxmlformats.org/officeDocument/2006/relationships" xmlns:p="http://schemas.openxmlformats.org/presentationml/2006/main">
-  <p:cSld>
-    <p:spTree>
-      <p:nvGrpSpPr>
-        <p:cNvPr id="1" name="">
-          <a:extLst>
-            <a:ext uri="{FF2B5EF4-FFF2-40B4-BE49-F238E27FC236}">
-              <a16:creationId xmlns:a16="http://schemas.microsoft.com/office/drawing/2014/main" id="{7FE2358C-3DED-8623-223A-38B520D15428}"/>
-            </a:ext>
-          </a:extLst>
-        </p:cNvPr>
-        <p:cNvGrpSpPr/>
-        <p:nvPr/>
-      </p:nvGrpSpPr>
-      <p:grpSpPr>
-        <a:xfrm>
-          <a:off x="0" y="0"/>
-          <a:ext cx="0" cy="0"/>
-          <a:chOff x="0" y="0"/>
-          <a:chExt cx="0" cy="0"/>
-        </a:xfrm>
-      </p:grpSpPr>
-      <p:sp>
-        <p:nvSpPr>
-          <p:cNvPr id="4" name="Title 3">
-            <a:extLst>
-              <a:ext uri="{FF2B5EF4-FFF2-40B4-BE49-F238E27FC236}">
-                <a16:creationId xmlns:a16="http://schemas.microsoft.com/office/drawing/2014/main" id="{C2166C8B-63A5-630A-051D-AED281BA7F24}"/>
-              </a:ext>
-            </a:extLst>
-          </p:cNvPr>
-          <p:cNvSpPr>
-            <a:spLocks noGrp="1"/>
-          </p:cNvSpPr>
-          <p:nvPr>
-            <p:ph type="title"/>
-          </p:nvPr>
-        </p:nvSpPr>
-        <p:spPr>
-          <a:xfrm>
-            <a:off x="838200" y="78206"/>
-            <a:ext cx="10515600" cy="1092110"/>
-          </a:xfrm>
-        </p:spPr>
-        <p:txBody>
-          <a:bodyPr>
-            <a:noAutofit/>
-          </a:bodyPr>
-          <a:lstStyle/>
-          <a:p>
-            <a:r>
-              <a:rPr lang="en-US" sz="2000" i="1" dirty="0"/>
-              <a:t>(alternative?) Supplemental Table 1</a:t>
-            </a:r>
-            <a:r>
-              <a:rPr lang="en-US" sz="2000" dirty="0"/>
-              <a:t>: Results of indicator species analysis (ISA) on net tows from four main clusters in the overall AHC. Max number of clusters that can be indicated together set equal to two. Used to verify the dominant taxa for each cluster and the use of clusters as representatives of taxa assemblages.</a:t>
-            </a:r>
-            <a:endParaRPr lang="en-US" sz="2000" i="1" dirty="0"/>
-          </a:p>
-        </p:txBody>
-      </p:sp>
-    </p:spTree>
-    <p:extLst>
-      <p:ext uri="{BB962C8B-B14F-4D97-AF65-F5344CB8AC3E}">
-        <p14:creationId xmlns:p14="http://schemas.microsoft.com/office/powerpoint/2010/main" val="646512240"/>
       </p:ext>
     </p:extLst>
   </p:cSld>

</xml_diff>